<commit_message>
redo script and outputs for missing species during BTG (april to october)
</commit_message>
<xml_diff>
--- a/figures/manual-edits/manuel-edits-btg.pptx
+++ b/figures/manual-edits/manuel-edits-btg.pptx
@@ -5,8 +5,9 @@
     <p:sldMasterId id="2147483660" r:id="rId1"/>
   </p:sldMasterIdLst>
   <p:sldIdLst>
-    <p:sldId id="256" r:id="rId2"/>
-    <p:sldId id="257" r:id="rId3"/>
+    <p:sldId id="257" r:id="rId2"/>
+    <p:sldId id="256" r:id="rId3"/>
+    <p:sldId id="258" r:id="rId4"/>
   </p:sldIdLst>
   <p:sldSz cx="6858000" cy="9144000" type="screen4x3"/>
   <p:notesSz cx="6858000" cy="9144000"/>
@@ -244,7 +245,7 @@
           <a:p>
             <a:fld id="{12FF8F91-EE85-BD43-9E1D-25AB87C02838}" type="datetimeFigureOut">
               <a:rPr lang="en-CA" smtClean="0"/>
-              <a:t>2026-04-30</a:t>
+              <a:t>2026-05-19</a:t>
             </a:fld>
             <a:endParaRPr lang="en-CA"/>
           </a:p>
@@ -414,7 +415,7 @@
           <a:p>
             <a:fld id="{12FF8F91-EE85-BD43-9E1D-25AB87C02838}" type="datetimeFigureOut">
               <a:rPr lang="en-CA" smtClean="0"/>
-              <a:t>2026-04-30</a:t>
+              <a:t>2026-05-19</a:t>
             </a:fld>
             <a:endParaRPr lang="en-CA"/>
           </a:p>
@@ -594,7 +595,7 @@
           <a:p>
             <a:fld id="{12FF8F91-EE85-BD43-9E1D-25AB87C02838}" type="datetimeFigureOut">
               <a:rPr lang="en-CA" smtClean="0"/>
-              <a:t>2026-04-30</a:t>
+              <a:t>2026-05-19</a:t>
             </a:fld>
             <a:endParaRPr lang="en-CA"/>
           </a:p>
@@ -764,7 +765,7 @@
           <a:p>
             <a:fld id="{12FF8F91-EE85-BD43-9E1D-25AB87C02838}" type="datetimeFigureOut">
               <a:rPr lang="en-CA" smtClean="0"/>
-              <a:t>2026-04-30</a:t>
+              <a:t>2026-05-19</a:t>
             </a:fld>
             <a:endParaRPr lang="en-CA"/>
           </a:p>
@@ -1010,7 +1011,7 @@
           <a:p>
             <a:fld id="{12FF8F91-EE85-BD43-9E1D-25AB87C02838}" type="datetimeFigureOut">
               <a:rPr lang="en-CA" smtClean="0"/>
-              <a:t>2026-04-30</a:t>
+              <a:t>2026-05-19</a:t>
             </a:fld>
             <a:endParaRPr lang="en-CA"/>
           </a:p>
@@ -1242,7 +1243,7 @@
           <a:p>
             <a:fld id="{12FF8F91-EE85-BD43-9E1D-25AB87C02838}" type="datetimeFigureOut">
               <a:rPr lang="en-CA" smtClean="0"/>
-              <a:t>2026-04-30</a:t>
+              <a:t>2026-05-19</a:t>
             </a:fld>
             <a:endParaRPr lang="en-CA"/>
           </a:p>
@@ -1609,7 +1610,7 @@
           <a:p>
             <a:fld id="{12FF8F91-EE85-BD43-9E1D-25AB87C02838}" type="datetimeFigureOut">
               <a:rPr lang="en-CA" smtClean="0"/>
-              <a:t>2026-04-30</a:t>
+              <a:t>2026-05-19</a:t>
             </a:fld>
             <a:endParaRPr lang="en-CA"/>
           </a:p>
@@ -1727,7 +1728,7 @@
           <a:p>
             <a:fld id="{12FF8F91-EE85-BD43-9E1D-25AB87C02838}" type="datetimeFigureOut">
               <a:rPr lang="en-CA" smtClean="0"/>
-              <a:t>2026-04-30</a:t>
+              <a:t>2026-05-19</a:t>
             </a:fld>
             <a:endParaRPr lang="en-CA"/>
           </a:p>
@@ -1822,7 +1823,7 @@
           <a:p>
             <a:fld id="{12FF8F91-EE85-BD43-9E1D-25AB87C02838}" type="datetimeFigureOut">
               <a:rPr lang="en-CA" smtClean="0"/>
-              <a:t>2026-04-30</a:t>
+              <a:t>2026-05-19</a:t>
             </a:fld>
             <a:endParaRPr lang="en-CA"/>
           </a:p>
@@ -2099,7 +2100,7 @@
           <a:p>
             <a:fld id="{12FF8F91-EE85-BD43-9E1D-25AB87C02838}" type="datetimeFigureOut">
               <a:rPr lang="en-CA" smtClean="0"/>
-              <a:t>2026-04-30</a:t>
+              <a:t>2026-05-19</a:t>
             </a:fld>
             <a:endParaRPr lang="en-CA"/>
           </a:p>
@@ -2356,7 +2357,7 @@
           <a:p>
             <a:fld id="{12FF8F91-EE85-BD43-9E1D-25AB87C02838}" type="datetimeFigureOut">
               <a:rPr lang="en-CA" smtClean="0"/>
-              <a:t>2026-04-30</a:t>
+              <a:t>2026-05-19</a:t>
             </a:fld>
             <a:endParaRPr lang="en-CA"/>
           </a:p>
@@ -2569,7 +2570,7 @@
           <a:p>
             <a:fld id="{12FF8F91-EE85-BD43-9E1D-25AB87C02838}" type="datetimeFigureOut">
               <a:rPr lang="en-CA" smtClean="0"/>
-              <a:t>2026-04-30</a:t>
+              <a:t>2026-05-19</a:t>
             </a:fld>
             <a:endParaRPr lang="en-CA"/>
           </a:p>
@@ -2958,6 +2959,341 @@
 </file>
 
 <file path=ppt/slides/slide1.xml><?xml version="1.0" encoding="utf-8"?>
+<p:sld xmlns:a="http://schemas.openxmlformats.org/drawingml/2006/main" xmlns:r="http://schemas.openxmlformats.org/officeDocument/2006/relationships" xmlns:p="http://schemas.openxmlformats.org/presentationml/2006/main">
+  <p:cSld>
+    <p:spTree>
+      <p:nvGrpSpPr>
+        <p:cNvPr id="1" name="">
+          <a:extLst>
+            <a:ext uri="{FF2B5EF4-FFF2-40B4-BE49-F238E27FC236}">
+              <a16:creationId xmlns:a16="http://schemas.microsoft.com/office/drawing/2014/main" id="{39B5E87D-88D0-2933-6F77-DF42748624B4}"/>
+            </a:ext>
+          </a:extLst>
+        </p:cNvPr>
+        <p:cNvGrpSpPr/>
+        <p:nvPr/>
+      </p:nvGrpSpPr>
+      <p:grpSpPr>
+        <a:xfrm>
+          <a:off x="0" y="0"/>
+          <a:ext cx="0" cy="0"/>
+          <a:chOff x="0" y="0"/>
+          <a:chExt cx="0" cy="0"/>
+        </a:xfrm>
+      </p:grpSpPr>
+      <p:grpSp>
+        <p:nvGrpSpPr>
+          <p:cNvPr id="17" name="Group 16">
+            <a:extLst>
+              <a:ext uri="{FF2B5EF4-FFF2-40B4-BE49-F238E27FC236}">
+                <a16:creationId xmlns:a16="http://schemas.microsoft.com/office/drawing/2014/main" id="{89290326-857C-15B6-46B0-C95FED3CCF51}"/>
+              </a:ext>
+            </a:extLst>
+          </p:cNvPr>
+          <p:cNvGrpSpPr/>
+          <p:nvPr/>
+        </p:nvGrpSpPr>
+        <p:grpSpPr>
+          <a:xfrm>
+            <a:off x="-689" y="0"/>
+            <a:ext cx="7157187" cy="9144000"/>
+            <a:chOff x="-689" y="0"/>
+            <a:chExt cx="7157187" cy="9144000"/>
+          </a:xfrm>
+        </p:grpSpPr>
+        <p:sp>
+          <p:nvSpPr>
+            <p:cNvPr id="6" name="Rectangle 5">
+              <a:extLst>
+                <a:ext uri="{FF2B5EF4-FFF2-40B4-BE49-F238E27FC236}">
+                  <a16:creationId xmlns:a16="http://schemas.microsoft.com/office/drawing/2014/main" id="{D8CD1728-45BB-F6CA-49F4-BB2DD8C937C8}"/>
+                </a:ext>
+              </a:extLst>
+            </p:cNvPr>
+            <p:cNvSpPr/>
+            <p:nvPr/>
+          </p:nvSpPr>
+          <p:spPr>
+            <a:xfrm>
+              <a:off x="0" y="0"/>
+              <a:ext cx="7156498" cy="9144000"/>
+            </a:xfrm>
+            <a:prstGeom prst="rect">
+              <a:avLst/>
+            </a:prstGeom>
+            <a:solidFill>
+              <a:schemeClr val="bg1"/>
+            </a:solidFill>
+            <a:ln>
+              <a:noFill/>
+            </a:ln>
+          </p:spPr>
+          <p:style>
+            <a:lnRef idx="2">
+              <a:schemeClr val="accent1">
+                <a:shade val="15000"/>
+              </a:schemeClr>
+            </a:lnRef>
+            <a:fillRef idx="1">
+              <a:schemeClr val="accent1"/>
+            </a:fillRef>
+            <a:effectRef idx="0">
+              <a:schemeClr val="accent1"/>
+            </a:effectRef>
+            <a:fontRef idx="minor">
+              <a:schemeClr val="lt1"/>
+            </a:fontRef>
+          </p:style>
+          <p:txBody>
+            <a:bodyPr rtlCol="0" anchor="ctr"/>
+            <a:lstStyle/>
+            <a:p>
+              <a:pPr algn="ctr"/>
+              <a:endParaRPr lang="en-CA"/>
+            </a:p>
+          </p:txBody>
+        </p:sp>
+        <p:pic>
+          <p:nvPicPr>
+            <p:cNvPr id="15" name="Picture 14" descr="A map of canada with different colored dots&#10;&#10;Description automatically generated">
+              <a:extLst>
+                <a:ext uri="{FF2B5EF4-FFF2-40B4-BE49-F238E27FC236}">
+                  <a16:creationId xmlns:a16="http://schemas.microsoft.com/office/drawing/2014/main" id="{9DDB5FB6-1541-21DD-F2A4-E296357598C7}"/>
+                </a:ext>
+              </a:extLst>
+            </p:cNvPr>
+            <p:cNvPicPr>
+              <a:picLocks noChangeAspect="1"/>
+            </p:cNvPicPr>
+            <p:nvPr/>
+          </p:nvPicPr>
+          <p:blipFill>
+            <a:blip r:embed="rId2"/>
+            <a:srcRect l="6744" t="11539" r="21752" b="11957"/>
+            <a:stretch/>
+          </p:blipFill>
+          <p:spPr>
+            <a:xfrm>
+              <a:off x="307471" y="226603"/>
+              <a:ext cx="6125554" cy="5243176"/>
+            </a:xfrm>
+            <a:prstGeom prst="rect">
+              <a:avLst/>
+            </a:prstGeom>
+          </p:spPr>
+        </p:pic>
+        <p:pic>
+          <p:nvPicPr>
+            <p:cNvPr id="16" name="Picture 15" descr="A map of canada with different colored dots&#10;&#10;Description automatically generated">
+              <a:extLst>
+                <a:ext uri="{FF2B5EF4-FFF2-40B4-BE49-F238E27FC236}">
+                  <a16:creationId xmlns:a16="http://schemas.microsoft.com/office/drawing/2014/main" id="{5BDF8C0D-17CF-9E01-257E-C6481EAC5C46}"/>
+                </a:ext>
+              </a:extLst>
+            </p:cNvPr>
+            <p:cNvPicPr>
+              <a:picLocks noChangeAspect="1"/>
+            </p:cNvPicPr>
+            <p:nvPr/>
+          </p:nvPicPr>
+          <p:blipFill>
+            <a:blip r:embed="rId2"/>
+            <a:srcRect l="82294" t="34757" r="4158" b="33883"/>
+            <a:stretch/>
+          </p:blipFill>
+          <p:spPr>
+            <a:xfrm>
+              <a:off x="5562857" y="273459"/>
+              <a:ext cx="1488499" cy="2756359"/>
+            </a:xfrm>
+            <a:prstGeom prst="rect">
+              <a:avLst/>
+            </a:prstGeom>
+          </p:spPr>
+        </p:pic>
+        <p:pic>
+          <p:nvPicPr>
+            <p:cNvPr id="7" name="Picture 6" descr="A graph with different colored bars&#10;&#10;Description automatically generated">
+              <a:extLst>
+                <a:ext uri="{FF2B5EF4-FFF2-40B4-BE49-F238E27FC236}">
+                  <a16:creationId xmlns:a16="http://schemas.microsoft.com/office/drawing/2014/main" id="{A3FA7D87-3B53-2BF0-9C68-D16C02B97217}"/>
+                </a:ext>
+              </a:extLst>
+            </p:cNvPr>
+            <p:cNvPicPr>
+              <a:picLocks noChangeAspect="1"/>
+            </p:cNvPicPr>
+            <p:nvPr/>
+          </p:nvPicPr>
+          <p:blipFill>
+            <a:blip r:embed="rId3"/>
+            <a:srcRect t="13750" b="13520"/>
+            <a:stretch/>
+          </p:blipFill>
+          <p:spPr>
+            <a:xfrm>
+              <a:off x="-689" y="5519886"/>
+              <a:ext cx="7055238" cy="3180038"/>
+            </a:xfrm>
+            <a:prstGeom prst="rect">
+              <a:avLst/>
+            </a:prstGeom>
+          </p:spPr>
+        </p:pic>
+        <p:sp>
+          <p:nvSpPr>
+            <p:cNvPr id="8" name="TextBox 7">
+              <a:extLst>
+                <a:ext uri="{FF2B5EF4-FFF2-40B4-BE49-F238E27FC236}">
+                  <a16:creationId xmlns:a16="http://schemas.microsoft.com/office/drawing/2014/main" id="{66F25BA0-2388-43C7-94BE-D4DB50D81229}"/>
+                </a:ext>
+              </a:extLst>
+            </p:cNvPr>
+            <p:cNvSpPr txBox="1"/>
+            <p:nvPr/>
+          </p:nvSpPr>
+          <p:spPr>
+            <a:xfrm>
+              <a:off x="4642593" y="8700594"/>
+              <a:ext cx="2133918" cy="338554"/>
+            </a:xfrm>
+            <a:prstGeom prst="rect">
+              <a:avLst/>
+            </a:prstGeom>
+            <a:solidFill>
+              <a:schemeClr val="bg1"/>
+            </a:solidFill>
+          </p:spPr>
+          <p:txBody>
+            <a:bodyPr wrap="none" rtlCol="0">
+              <a:spAutoFit/>
+            </a:bodyPr>
+            <a:lstStyle/>
+            <a:p>
+              <a:r>
+                <a:rPr lang="en-CA" sz="1600" b="1" dirty="0">
+                  <a:latin typeface="Roboto Condensed" pitchFamily="2" charset="0"/>
+                  <a:ea typeface="Roboto Condensed" pitchFamily="2" charset="0"/>
+                </a:rPr>
+                <a:t>Newly recorded species</a:t>
+              </a:r>
+            </a:p>
+          </p:txBody>
+        </p:sp>
+        <p:pic>
+          <p:nvPicPr>
+            <p:cNvPr id="4" name="Picture 3" descr="A map of canada with different colored dots&#10;&#10;Description automatically generated">
+              <a:extLst>
+                <a:ext uri="{FF2B5EF4-FFF2-40B4-BE49-F238E27FC236}">
+                  <a16:creationId xmlns:a16="http://schemas.microsoft.com/office/drawing/2014/main" id="{B191DDEC-C379-A696-6BEC-1F27EB099405}"/>
+                </a:ext>
+              </a:extLst>
+            </p:cNvPr>
+            <p:cNvPicPr>
+              <a:picLocks noChangeAspect="1"/>
+            </p:cNvPicPr>
+            <p:nvPr/>
+          </p:nvPicPr>
+          <p:blipFill>
+            <a:blip r:embed="rId4"/>
+            <a:srcRect l="83327" t="34490" r="2753" b="32364"/>
+            <a:stretch/>
+          </p:blipFill>
+          <p:spPr>
+            <a:xfrm>
+              <a:off x="5709552" y="274129"/>
+              <a:ext cx="1446946" cy="2756359"/>
+            </a:xfrm>
+            <a:prstGeom prst="rect">
+              <a:avLst/>
+            </a:prstGeom>
+          </p:spPr>
+        </p:pic>
+        <p:sp>
+          <p:nvSpPr>
+            <p:cNvPr id="11" name="TextBox 10">
+              <a:extLst>
+                <a:ext uri="{FF2B5EF4-FFF2-40B4-BE49-F238E27FC236}">
+                  <a16:creationId xmlns:a16="http://schemas.microsoft.com/office/drawing/2014/main" id="{B3DAB614-A62A-040C-781B-043EF8D570C6}"/>
+                </a:ext>
+              </a:extLst>
+            </p:cNvPr>
+            <p:cNvSpPr txBox="1"/>
+            <p:nvPr/>
+          </p:nvSpPr>
+          <p:spPr>
+            <a:xfrm>
+              <a:off x="164601" y="302145"/>
+              <a:ext cx="348172" cy="461665"/>
+            </a:xfrm>
+            <a:prstGeom prst="rect">
+              <a:avLst/>
+            </a:prstGeom>
+            <a:noFill/>
+          </p:spPr>
+          <p:txBody>
+            <a:bodyPr wrap="none" rtlCol="0">
+              <a:spAutoFit/>
+            </a:bodyPr>
+            <a:lstStyle/>
+            <a:p>
+              <a:r>
+                <a:rPr lang="en-CA" sz="2400" dirty="0"/>
+                <a:t>a</a:t>
+              </a:r>
+            </a:p>
+          </p:txBody>
+        </p:sp>
+        <p:sp>
+          <p:nvSpPr>
+            <p:cNvPr id="12" name="TextBox 11">
+              <a:extLst>
+                <a:ext uri="{FF2B5EF4-FFF2-40B4-BE49-F238E27FC236}">
+                  <a16:creationId xmlns:a16="http://schemas.microsoft.com/office/drawing/2014/main" id="{B565BB86-8733-396A-8635-73399EBF2CAC}"/>
+                </a:ext>
+              </a:extLst>
+            </p:cNvPr>
+            <p:cNvSpPr txBox="1"/>
+            <p:nvPr/>
+          </p:nvSpPr>
+          <p:spPr>
+            <a:xfrm>
+              <a:off x="154983" y="5465549"/>
+              <a:ext cx="357790" cy="461665"/>
+            </a:xfrm>
+            <a:prstGeom prst="rect">
+              <a:avLst/>
+            </a:prstGeom>
+            <a:noFill/>
+          </p:spPr>
+          <p:txBody>
+            <a:bodyPr wrap="none" rtlCol="0">
+              <a:spAutoFit/>
+            </a:bodyPr>
+            <a:lstStyle/>
+            <a:p>
+              <a:r>
+                <a:rPr lang="en-CA" sz="2400" dirty="0"/>
+                <a:t>b</a:t>
+              </a:r>
+            </a:p>
+          </p:txBody>
+        </p:sp>
+      </p:grpSp>
+    </p:spTree>
+    <p:extLst>
+      <p:ext uri="{BB962C8B-B14F-4D97-AF65-F5344CB8AC3E}">
+        <p14:creationId xmlns:p14="http://schemas.microsoft.com/office/powerpoint/2010/main" val="473365066"/>
+      </p:ext>
+    </p:extLst>
+  </p:cSld>
+  <p:clrMapOvr>
+    <a:masterClrMapping/>
+  </p:clrMapOvr>
+</p:sld>
+</file>
+
+<file path=ppt/slides/slide2.xml><?xml version="1.0" encoding="utf-8"?>
 <p:sld xmlns:a="http://schemas.openxmlformats.org/drawingml/2006/main" xmlns:r="http://schemas.openxmlformats.org/officeDocument/2006/relationships" xmlns:p="http://schemas.openxmlformats.org/presentationml/2006/main">
   <p:cSld>
     <p:spTree>
@@ -3299,7 +3635,7 @@
 </p:sld>
 </file>
 
-<file path=ppt/slides/slide2.xml><?xml version="1.0" encoding="utf-8"?>
+<file path=ppt/slides/slide3.xml><?xml version="1.0" encoding="utf-8"?>
 <p:sld xmlns:a="http://schemas.openxmlformats.org/drawingml/2006/main" xmlns:r="http://schemas.openxmlformats.org/officeDocument/2006/relationships" xmlns:p="http://schemas.openxmlformats.org/presentationml/2006/main">
   <p:cSld>
     <p:spTree>
@@ -3307,7 +3643,7 @@
         <p:cNvPr id="1" name="">
           <a:extLst>
             <a:ext uri="{FF2B5EF4-FFF2-40B4-BE49-F238E27FC236}">
-              <a16:creationId xmlns:a16="http://schemas.microsoft.com/office/drawing/2014/main" id="{39B5E87D-88D0-2933-6F77-DF42748624B4}"/>
+              <a16:creationId xmlns:a16="http://schemas.microsoft.com/office/drawing/2014/main" id="{F3997E9C-E6FE-43FA-992E-A1F9FEA47F9F}"/>
             </a:ext>
           </a:extLst>
         </p:cNvPr>
@@ -3327,7 +3663,7 @@
           <p:cNvPr id="14" name="Group 13">
             <a:extLst>
               <a:ext uri="{FF2B5EF4-FFF2-40B4-BE49-F238E27FC236}">
-                <a16:creationId xmlns:a16="http://schemas.microsoft.com/office/drawing/2014/main" id="{F3CE414D-F112-FD03-FBDD-8188E8ECD75C}"/>
+                <a16:creationId xmlns:a16="http://schemas.microsoft.com/office/drawing/2014/main" id="{19FBC6BA-3480-D6E9-8FDA-5475E2059D1C}"/>
               </a:ext>
             </a:extLst>
           </p:cNvPr>
@@ -3347,7 +3683,7 @@
             <p:cNvPr id="6" name="Rectangle 5">
               <a:extLst>
                 <a:ext uri="{FF2B5EF4-FFF2-40B4-BE49-F238E27FC236}">
-                  <a16:creationId xmlns:a16="http://schemas.microsoft.com/office/drawing/2014/main" id="{D8CD1728-45BB-F6CA-49F4-BB2DD8C937C8}"/>
+                  <a16:creationId xmlns:a16="http://schemas.microsoft.com/office/drawing/2014/main" id="{1F1248A5-71CE-EEFB-AA79-8E81E9F74AC3}"/>
                 </a:ext>
               </a:extLst>
             </p:cNvPr>
@@ -3399,7 +3735,7 @@
             <p:cNvPr id="13" name="Group 12">
               <a:extLst>
                 <a:ext uri="{FF2B5EF4-FFF2-40B4-BE49-F238E27FC236}">
-                  <a16:creationId xmlns:a16="http://schemas.microsoft.com/office/drawing/2014/main" id="{FFB30861-3910-678F-2E66-904DB96AFAB8}"/>
+                  <a16:creationId xmlns:a16="http://schemas.microsoft.com/office/drawing/2014/main" id="{D23461D6-8C5B-3FA5-AB3C-7B6A520DD636}"/>
                 </a:ext>
               </a:extLst>
             </p:cNvPr>
@@ -3419,7 +3755,7 @@
               <p:cNvPr id="10" name="Group 9">
                 <a:extLst>
                   <a:ext uri="{FF2B5EF4-FFF2-40B4-BE49-F238E27FC236}">
-                    <a16:creationId xmlns:a16="http://schemas.microsoft.com/office/drawing/2014/main" id="{90EB719E-75F2-5B0A-6355-16644AC4B924}"/>
+                    <a16:creationId xmlns:a16="http://schemas.microsoft.com/office/drawing/2014/main" id="{89B4581D-22E1-09FB-CE3E-0A21C5E34726}"/>
                   </a:ext>
                 </a:extLst>
               </p:cNvPr>
@@ -3439,7 +3775,7 @@
                 <p:cNvPr id="5" name="Picture 4" descr="A graph with different colored bars&#10;&#10;Description automatically generated">
                   <a:extLst>
                     <a:ext uri="{FF2B5EF4-FFF2-40B4-BE49-F238E27FC236}">
-                      <a16:creationId xmlns:a16="http://schemas.microsoft.com/office/drawing/2014/main" id="{71A638E0-AF22-3504-AF02-84A54AB5B921}"/>
+                      <a16:creationId xmlns:a16="http://schemas.microsoft.com/office/drawing/2014/main" id="{C85D9ABE-1AB0-B4EF-3139-32BD50268D13}"/>
                     </a:ext>
                   </a:extLst>
                 </p:cNvPr>
@@ -3468,7 +3804,7 @@
                 <p:cNvPr id="8" name="TextBox 7">
                   <a:extLst>
                     <a:ext uri="{FF2B5EF4-FFF2-40B4-BE49-F238E27FC236}">
-                      <a16:creationId xmlns:a16="http://schemas.microsoft.com/office/drawing/2014/main" id="{66F25BA0-2388-43C7-94BE-D4DB50D81229}"/>
+                      <a16:creationId xmlns:a16="http://schemas.microsoft.com/office/drawing/2014/main" id="{FFCD5895-215E-B245-B1F8-470B38B85146}"/>
                     </a:ext>
                   </a:extLst>
                 </p:cNvPr>
@@ -3509,7 +3845,7 @@
               <p:cNvPr id="11" name="TextBox 10">
                 <a:extLst>
                   <a:ext uri="{FF2B5EF4-FFF2-40B4-BE49-F238E27FC236}">
-                    <a16:creationId xmlns:a16="http://schemas.microsoft.com/office/drawing/2014/main" id="{B3DAB614-A62A-040C-781B-043EF8D570C6}"/>
+                    <a16:creationId xmlns:a16="http://schemas.microsoft.com/office/drawing/2014/main" id="{C5043B77-EFCD-5A11-E759-1B3D45D517F5}"/>
                   </a:ext>
                 </a:extLst>
               </p:cNvPr>
@@ -3544,7 +3880,7 @@
               <p:cNvPr id="12" name="TextBox 11">
                 <a:extLst>
                   <a:ext uri="{FF2B5EF4-FFF2-40B4-BE49-F238E27FC236}">
-                    <a16:creationId xmlns:a16="http://schemas.microsoft.com/office/drawing/2014/main" id="{B565BB86-8733-396A-8635-73399EBF2CAC}"/>
+                    <a16:creationId xmlns:a16="http://schemas.microsoft.com/office/drawing/2014/main" id="{636034AF-40BE-04E8-239F-8AFA6294F7B9}"/>
                   </a:ext>
                 </a:extLst>
               </p:cNvPr>
@@ -3580,7 +3916,7 @@
             <p:cNvPr id="3" name="Picture 2" descr="A map of canada with different colored dots&#10;&#10;Description automatically generated">
               <a:extLst>
                 <a:ext uri="{FF2B5EF4-FFF2-40B4-BE49-F238E27FC236}">
-                  <a16:creationId xmlns:a16="http://schemas.microsoft.com/office/drawing/2014/main" id="{E46CBEAB-EF3F-572B-5543-9B4EE20D06AD}"/>
+                  <a16:creationId xmlns:a16="http://schemas.microsoft.com/office/drawing/2014/main" id="{6E664AE0-AF60-C6E6-8C2C-27A8ED62DC3E}"/>
                 </a:ext>
               </a:extLst>
             </p:cNvPr>
@@ -3609,7 +3945,7 @@
             <p:cNvPr id="4" name="Picture 3" descr="A map of canada with different colored dots&#10;&#10;Description automatically generated">
               <a:extLst>
                 <a:ext uri="{FF2B5EF4-FFF2-40B4-BE49-F238E27FC236}">
-                  <a16:creationId xmlns:a16="http://schemas.microsoft.com/office/drawing/2014/main" id="{B191DDEC-C379-A696-6BEC-1F27EB099405}"/>
+                  <a16:creationId xmlns:a16="http://schemas.microsoft.com/office/drawing/2014/main" id="{64B36A06-37B6-C0B8-E912-E308B9111627}"/>
                 </a:ext>
               </a:extLst>
             </p:cNvPr>
@@ -3637,7 +3973,7 @@
     </p:spTree>
     <p:extLst>
       <p:ext uri="{BB962C8B-B14F-4D97-AF65-F5344CB8AC3E}">
-        <p14:creationId xmlns:p14="http://schemas.microsoft.com/office/powerpoint/2010/main" val="473365066"/>
+        <p14:creationId xmlns:p14="http://schemas.microsoft.com/office/powerpoint/2010/main" val="4268398962"/>
       </p:ext>
     </p:extLst>
   </p:cSld>

</xml_diff>

<commit_message>
update with corrected 'new sp' list
</commit_message>
<xml_diff>
--- a/figures/manual-edits/manuel-edits-btg.pptx
+++ b/figures/manual-edits/manuel-edits-btg.pptx
@@ -6,8 +6,9 @@
   </p:sldMasterIdLst>
   <p:sldIdLst>
     <p:sldId id="257" r:id="rId2"/>
-    <p:sldId id="256" r:id="rId3"/>
-    <p:sldId id="258" r:id="rId4"/>
+    <p:sldId id="259" r:id="rId3"/>
+    <p:sldId id="256" r:id="rId4"/>
+    <p:sldId id="258" r:id="rId5"/>
   </p:sldIdLst>
   <p:sldSz cx="6858000" cy="9144000" type="screen4x3"/>
   <p:notesSz cx="6858000" cy="9144000"/>
@@ -245,7 +246,7 @@
           <a:p>
             <a:fld id="{12FF8F91-EE85-BD43-9E1D-25AB87C02838}" type="datetimeFigureOut">
               <a:rPr lang="en-CA" smtClean="0"/>
-              <a:t>2026-05-19</a:t>
+              <a:t>2026-06-10</a:t>
             </a:fld>
             <a:endParaRPr lang="en-CA"/>
           </a:p>
@@ -415,7 +416,7 @@
           <a:p>
             <a:fld id="{12FF8F91-EE85-BD43-9E1D-25AB87C02838}" type="datetimeFigureOut">
               <a:rPr lang="en-CA" smtClean="0"/>
-              <a:t>2026-05-19</a:t>
+              <a:t>2026-06-10</a:t>
             </a:fld>
             <a:endParaRPr lang="en-CA"/>
           </a:p>
@@ -595,7 +596,7 @@
           <a:p>
             <a:fld id="{12FF8F91-EE85-BD43-9E1D-25AB87C02838}" type="datetimeFigureOut">
               <a:rPr lang="en-CA" smtClean="0"/>
-              <a:t>2026-05-19</a:t>
+              <a:t>2026-06-10</a:t>
             </a:fld>
             <a:endParaRPr lang="en-CA"/>
           </a:p>
@@ -765,7 +766,7 @@
           <a:p>
             <a:fld id="{12FF8F91-EE85-BD43-9E1D-25AB87C02838}" type="datetimeFigureOut">
               <a:rPr lang="en-CA" smtClean="0"/>
-              <a:t>2026-05-19</a:t>
+              <a:t>2026-06-10</a:t>
             </a:fld>
             <a:endParaRPr lang="en-CA"/>
           </a:p>
@@ -1011,7 +1012,7 @@
           <a:p>
             <a:fld id="{12FF8F91-EE85-BD43-9E1D-25AB87C02838}" type="datetimeFigureOut">
               <a:rPr lang="en-CA" smtClean="0"/>
-              <a:t>2026-05-19</a:t>
+              <a:t>2026-06-10</a:t>
             </a:fld>
             <a:endParaRPr lang="en-CA"/>
           </a:p>
@@ -1243,7 +1244,7 @@
           <a:p>
             <a:fld id="{12FF8F91-EE85-BD43-9E1D-25AB87C02838}" type="datetimeFigureOut">
               <a:rPr lang="en-CA" smtClean="0"/>
-              <a:t>2026-05-19</a:t>
+              <a:t>2026-06-10</a:t>
             </a:fld>
             <a:endParaRPr lang="en-CA"/>
           </a:p>
@@ -1610,7 +1611,7 @@
           <a:p>
             <a:fld id="{12FF8F91-EE85-BD43-9E1D-25AB87C02838}" type="datetimeFigureOut">
               <a:rPr lang="en-CA" smtClean="0"/>
-              <a:t>2026-05-19</a:t>
+              <a:t>2026-06-10</a:t>
             </a:fld>
             <a:endParaRPr lang="en-CA"/>
           </a:p>
@@ -1728,7 +1729,7 @@
           <a:p>
             <a:fld id="{12FF8F91-EE85-BD43-9E1D-25AB87C02838}" type="datetimeFigureOut">
               <a:rPr lang="en-CA" smtClean="0"/>
-              <a:t>2026-05-19</a:t>
+              <a:t>2026-06-10</a:t>
             </a:fld>
             <a:endParaRPr lang="en-CA"/>
           </a:p>
@@ -1823,7 +1824,7 @@
           <a:p>
             <a:fld id="{12FF8F91-EE85-BD43-9E1D-25AB87C02838}" type="datetimeFigureOut">
               <a:rPr lang="en-CA" smtClean="0"/>
-              <a:t>2026-05-19</a:t>
+              <a:t>2026-06-10</a:t>
             </a:fld>
             <a:endParaRPr lang="en-CA"/>
           </a:p>
@@ -2100,7 +2101,7 @@
           <a:p>
             <a:fld id="{12FF8F91-EE85-BD43-9E1D-25AB87C02838}" type="datetimeFigureOut">
               <a:rPr lang="en-CA" smtClean="0"/>
-              <a:t>2026-05-19</a:t>
+              <a:t>2026-06-10</a:t>
             </a:fld>
             <a:endParaRPr lang="en-CA"/>
           </a:p>
@@ -2357,7 +2358,7 @@
           <a:p>
             <a:fld id="{12FF8F91-EE85-BD43-9E1D-25AB87C02838}" type="datetimeFigureOut">
               <a:rPr lang="en-CA" smtClean="0"/>
-              <a:t>2026-05-19</a:t>
+              <a:t>2026-06-10</a:t>
             </a:fld>
             <a:endParaRPr lang="en-CA"/>
           </a:p>
@@ -2570,7 +2571,7 @@
           <a:p>
             <a:fld id="{12FF8F91-EE85-BD43-9E1D-25AB87C02838}" type="datetimeFigureOut">
               <a:rPr lang="en-CA" smtClean="0"/>
-              <a:t>2026-05-19</a:t>
+              <a:t>2026-06-10</a:t>
             </a:fld>
             <a:endParaRPr lang="en-CA"/>
           </a:p>
@@ -2983,10 +2984,10 @@
       </p:grpSpPr>
       <p:grpSp>
         <p:nvGrpSpPr>
-          <p:cNvPr id="17" name="Group 16">
+          <p:cNvPr id="38" name="Group 37">
             <a:extLst>
               <a:ext uri="{FF2B5EF4-FFF2-40B4-BE49-F238E27FC236}">
-                <a16:creationId xmlns:a16="http://schemas.microsoft.com/office/drawing/2014/main" id="{89290326-857C-15B6-46B0-C95FED3CCF51}"/>
+                <a16:creationId xmlns:a16="http://schemas.microsoft.com/office/drawing/2014/main" id="{F364958C-4FE4-6C9D-2E24-C898BA47BC9E}"/>
               </a:ext>
             </a:extLst>
           </p:cNvPr>
@@ -2995,10 +2996,10 @@
         </p:nvGrpSpPr>
         <p:grpSpPr>
           <a:xfrm>
-            <a:off x="-689" y="0"/>
-            <a:ext cx="7157187" cy="9144000"/>
-            <a:chOff x="-689" y="0"/>
-            <a:chExt cx="7157187" cy="9144000"/>
+            <a:off x="4160" y="-6103"/>
+            <a:ext cx="7156498" cy="9144000"/>
+            <a:chOff x="4160" y="-6103"/>
+            <a:chExt cx="7156498" cy="9144000"/>
           </a:xfrm>
         </p:grpSpPr>
         <p:sp>
@@ -3015,7 +3016,7 @@
           </p:nvSpPr>
           <p:spPr>
             <a:xfrm>
-              <a:off x="0" y="0"/>
+              <a:off x="4160" y="-6103"/>
               <a:ext cx="7156498" cy="9144000"/>
             </a:xfrm>
             <a:prstGeom prst="rect">
@@ -3055,10 +3056,10 @@
         </p:sp>
         <p:pic>
           <p:nvPicPr>
-            <p:cNvPr id="15" name="Picture 14" descr="A map of canada with different colored dots&#10;&#10;Description automatically generated">
+            <p:cNvPr id="34" name="Picture 33" descr="A map of canada with different colored dots&#10;&#10;Description automatically generated">
               <a:extLst>
                 <a:ext uri="{FF2B5EF4-FFF2-40B4-BE49-F238E27FC236}">
-                  <a16:creationId xmlns:a16="http://schemas.microsoft.com/office/drawing/2014/main" id="{9DDB5FB6-1541-21DD-F2A4-E296357598C7}"/>
+                  <a16:creationId xmlns:a16="http://schemas.microsoft.com/office/drawing/2014/main" id="{BE0C0BFB-BD88-C51D-0BBE-B202EB175BBA}"/>
                 </a:ext>
               </a:extLst>
             </p:cNvPr>
@@ -3068,14 +3069,16 @@
             <p:nvPr/>
           </p:nvPicPr>
           <p:blipFill>
-            <a:blip r:embed="rId2"/>
-            <a:srcRect l="6744" t="11539" r="21752" b="11957"/>
+            <a:blip r:embed="rId2">
+              <a:alphaModFix/>
+            </a:blip>
+            <a:srcRect l="7487" t="10460" r="22151" b="12371"/>
             <a:stretch/>
           </p:blipFill>
           <p:spPr>
             <a:xfrm>
-              <a:off x="307471" y="226603"/>
-              <a:ext cx="6125554" cy="5243176"/>
+              <a:off x="334567" y="104852"/>
+              <a:ext cx="6109905" cy="5360697"/>
             </a:xfrm>
             <a:prstGeom prst="rect">
               <a:avLst/>
@@ -3084,10 +3087,10 @@
         </p:pic>
         <p:pic>
           <p:nvPicPr>
-            <p:cNvPr id="16" name="Picture 15" descr="A map of canada with different colored dots&#10;&#10;Description automatically generated">
+            <p:cNvPr id="35" name="Picture 34" descr="A map of canada with different colored dots&#10;&#10;Description automatically generated">
               <a:extLst>
                 <a:ext uri="{FF2B5EF4-FFF2-40B4-BE49-F238E27FC236}">
-                  <a16:creationId xmlns:a16="http://schemas.microsoft.com/office/drawing/2014/main" id="{5BDF8C0D-17CF-9E01-257E-C6481EAC5C46}"/>
+                  <a16:creationId xmlns:a16="http://schemas.microsoft.com/office/drawing/2014/main" id="{555F416F-F1CD-7C4D-C036-F3955642A9E3}"/>
                 </a:ext>
               </a:extLst>
             </p:cNvPr>
@@ -3097,14 +3100,16 @@
             <p:nvPr/>
           </p:nvPicPr>
           <p:blipFill>
-            <a:blip r:embed="rId2"/>
-            <a:srcRect l="82294" t="34757" r="4158" b="33883"/>
+            <a:blip r:embed="rId2">
+              <a:alphaModFix/>
+            </a:blip>
+            <a:srcRect l="82336" t="35710" r="3007" b="32869"/>
             <a:stretch/>
           </p:blipFill>
           <p:spPr>
             <a:xfrm>
-              <a:off x="5562857" y="273459"/>
-              <a:ext cx="1488499" cy="2756359"/>
+              <a:off x="5352566" y="177922"/>
+              <a:ext cx="1702672" cy="2920181"/>
             </a:xfrm>
             <a:prstGeom prst="rect">
               <a:avLst/>
@@ -3113,10 +3118,10 @@
         </p:pic>
         <p:pic>
           <p:nvPicPr>
-            <p:cNvPr id="7" name="Picture 6" descr="A graph with different colored bars&#10;&#10;Description automatically generated">
+            <p:cNvPr id="37" name="Picture 36" descr="A graph with different colored bars&#10;&#10;Description automatically generated">
               <a:extLst>
                 <a:ext uri="{FF2B5EF4-FFF2-40B4-BE49-F238E27FC236}">
-                  <a16:creationId xmlns:a16="http://schemas.microsoft.com/office/drawing/2014/main" id="{A3FA7D87-3B53-2BF0-9C68-D16C02B97217}"/>
+                  <a16:creationId xmlns:a16="http://schemas.microsoft.com/office/drawing/2014/main" id="{FA627CAB-DA63-28B4-2A23-AFBBDA6C995A}"/>
                 </a:ext>
               </a:extLst>
             </p:cNvPr>
@@ -3127,13 +3132,13 @@
           </p:nvPicPr>
           <p:blipFill>
             <a:blip r:embed="rId3"/>
-            <a:srcRect t="13750" b="13520"/>
+            <a:srcRect l="7258" t="16289" r="3651" b="13029"/>
             <a:stretch/>
           </p:blipFill>
           <p:spPr>
             <a:xfrm>
-              <a:off x="-689" y="5519886"/>
-              <a:ext cx="7055238" cy="3180038"/>
+              <a:off x="309505" y="5519887"/>
+              <a:ext cx="6467695" cy="3180038"/>
             </a:xfrm>
             <a:prstGeom prst="rect">
               <a:avLst/>
@@ -3142,10 +3147,10 @@
         </p:pic>
         <p:sp>
           <p:nvSpPr>
-            <p:cNvPr id="8" name="TextBox 7">
+            <p:cNvPr id="12" name="TextBox 11">
               <a:extLst>
                 <a:ext uri="{FF2B5EF4-FFF2-40B4-BE49-F238E27FC236}">
-                  <a16:creationId xmlns:a16="http://schemas.microsoft.com/office/drawing/2014/main" id="{66F25BA0-2388-43C7-94BE-D4DB50D81229}"/>
+                  <a16:creationId xmlns:a16="http://schemas.microsoft.com/office/drawing/2014/main" id="{B565BB86-8733-396A-8635-73399EBF2CAC}"/>
                 </a:ext>
               </a:extLst>
             </p:cNvPr>
@@ -3154,15 +3159,13 @@
           </p:nvSpPr>
           <p:spPr>
             <a:xfrm>
-              <a:off x="4642593" y="8700594"/>
-              <a:ext cx="2133918" cy="338554"/>
+              <a:off x="312919" y="5452016"/>
+              <a:ext cx="357790" cy="461665"/>
             </a:xfrm>
             <a:prstGeom prst="rect">
               <a:avLst/>
             </a:prstGeom>
-            <a:solidFill>
-              <a:schemeClr val="bg1"/>
-            </a:solidFill>
+            <a:noFill/>
           </p:spPr>
           <p:txBody>
             <a:bodyPr wrap="none" rtlCol="0">
@@ -3171,44 +3174,12 @@
             <a:lstStyle/>
             <a:p>
               <a:r>
-                <a:rPr lang="en-CA" sz="1600" b="1" dirty="0">
-                  <a:latin typeface="Roboto Condensed" pitchFamily="2" charset="0"/>
-                  <a:ea typeface="Roboto Condensed" pitchFamily="2" charset="0"/>
-                </a:rPr>
-                <a:t>Newly recorded species</a:t>
+                <a:rPr lang="en-CA" sz="2400" dirty="0"/>
+                <a:t>b</a:t>
               </a:r>
             </a:p>
           </p:txBody>
         </p:sp>
-        <p:pic>
-          <p:nvPicPr>
-            <p:cNvPr id="4" name="Picture 3" descr="A map of canada with different colored dots&#10;&#10;Description automatically generated">
-              <a:extLst>
-                <a:ext uri="{FF2B5EF4-FFF2-40B4-BE49-F238E27FC236}">
-                  <a16:creationId xmlns:a16="http://schemas.microsoft.com/office/drawing/2014/main" id="{B191DDEC-C379-A696-6BEC-1F27EB099405}"/>
-                </a:ext>
-              </a:extLst>
-            </p:cNvPr>
-            <p:cNvPicPr>
-              <a:picLocks noChangeAspect="1"/>
-            </p:cNvPicPr>
-            <p:nvPr/>
-          </p:nvPicPr>
-          <p:blipFill>
-            <a:blip r:embed="rId4"/>
-            <a:srcRect l="83327" t="34490" r="2753" b="32364"/>
-            <a:stretch/>
-          </p:blipFill>
-          <p:spPr>
-            <a:xfrm>
-              <a:off x="5709552" y="274129"/>
-              <a:ext cx="1446946" cy="2756359"/>
-            </a:xfrm>
-            <a:prstGeom prst="rect">
-              <a:avLst/>
-            </a:prstGeom>
-          </p:spPr>
-        </p:pic>
         <p:sp>
           <p:nvSpPr>
             <p:cNvPr id="11" name="TextBox 10">
@@ -3223,7 +3194,7 @@
           </p:nvSpPr>
           <p:spPr>
             <a:xfrm>
-              <a:off x="164601" y="302145"/>
+              <a:off x="413528" y="177922"/>
               <a:ext cx="348172" cy="461665"/>
             </a:xfrm>
             <a:prstGeom prst="rect">
@@ -3246,10 +3217,10 @@
         </p:sp>
         <p:sp>
           <p:nvSpPr>
-            <p:cNvPr id="12" name="TextBox 11">
+            <p:cNvPr id="8" name="TextBox 7">
               <a:extLst>
                 <a:ext uri="{FF2B5EF4-FFF2-40B4-BE49-F238E27FC236}">
-                  <a16:creationId xmlns:a16="http://schemas.microsoft.com/office/drawing/2014/main" id="{B565BB86-8733-396A-8635-73399EBF2CAC}"/>
+                  <a16:creationId xmlns:a16="http://schemas.microsoft.com/office/drawing/2014/main" id="{66F25BA0-2388-43C7-94BE-D4DB50D81229}"/>
                 </a:ext>
               </a:extLst>
             </p:cNvPr>
@@ -3258,23 +3229,29 @@
           </p:nvSpPr>
           <p:spPr>
             <a:xfrm>
-              <a:off x="154983" y="5465549"/>
-              <a:ext cx="357790" cy="461665"/>
+              <a:off x="3273252" y="8734245"/>
+              <a:ext cx="3348200" cy="369332"/>
             </a:xfrm>
             <a:prstGeom prst="rect">
               <a:avLst/>
             </a:prstGeom>
-            <a:noFill/>
+            <a:solidFill>
+              <a:schemeClr val="bg1"/>
+            </a:solidFill>
           </p:spPr>
           <p:txBody>
-            <a:bodyPr wrap="none" rtlCol="0">
+            <a:bodyPr wrap="square" rtlCol="0">
               <a:spAutoFit/>
             </a:bodyPr>
             <a:lstStyle/>
             <a:p>
+              <a:pPr algn="r"/>
               <a:r>
-                <a:rPr lang="en-CA" sz="2400" dirty="0"/>
-                <a:t>b</a:t>
+                <a:rPr lang="en-CA" b="1" dirty="0">
+                  <a:latin typeface="Roboto Condensed" pitchFamily="2" charset="0"/>
+                  <a:ea typeface="Roboto Condensed" pitchFamily="2" charset="0"/>
+                </a:rPr>
+                <a:t>Newly recorded species</a:t>
               </a:r>
             </a:p>
           </p:txBody>
@@ -3294,6 +3271,1652 @@
 </file>
 
 <file path=ppt/slides/slide2.xml><?xml version="1.0" encoding="utf-8"?>
+<p:sld xmlns:a="http://schemas.openxmlformats.org/drawingml/2006/main" xmlns:r="http://schemas.openxmlformats.org/officeDocument/2006/relationships" xmlns:p="http://schemas.openxmlformats.org/presentationml/2006/main">
+  <p:cSld>
+    <p:spTree>
+      <p:nvGrpSpPr>
+        <p:cNvPr id="1" name="">
+          <a:extLst>
+            <a:ext uri="{FF2B5EF4-FFF2-40B4-BE49-F238E27FC236}">
+              <a16:creationId xmlns:a16="http://schemas.microsoft.com/office/drawing/2014/main" id="{BBE3A930-2443-1800-4D9A-D1919C495EB8}"/>
+            </a:ext>
+          </a:extLst>
+        </p:cNvPr>
+        <p:cNvGrpSpPr/>
+        <p:nvPr/>
+      </p:nvGrpSpPr>
+      <p:grpSpPr>
+        <a:xfrm>
+          <a:off x="0" y="0"/>
+          <a:ext cx="0" cy="0"/>
+          <a:chOff x="0" y="0"/>
+          <a:chExt cx="0" cy="0"/>
+        </a:xfrm>
+      </p:grpSpPr>
+      <p:grpSp>
+        <p:nvGrpSpPr>
+          <p:cNvPr id="56" name="Group 55">
+            <a:extLst>
+              <a:ext uri="{FF2B5EF4-FFF2-40B4-BE49-F238E27FC236}">
+                <a16:creationId xmlns:a16="http://schemas.microsoft.com/office/drawing/2014/main" id="{6436A836-3051-B4D5-36EB-1A7CB84AA483}"/>
+              </a:ext>
+            </a:extLst>
+          </p:cNvPr>
+          <p:cNvGrpSpPr/>
+          <p:nvPr/>
+        </p:nvGrpSpPr>
+        <p:grpSpPr>
+          <a:xfrm>
+            <a:off x="0" y="0"/>
+            <a:ext cx="7157187" cy="9144000"/>
+            <a:chOff x="0" y="0"/>
+            <a:chExt cx="7157187" cy="9144000"/>
+          </a:xfrm>
+        </p:grpSpPr>
+        <p:grpSp>
+          <p:nvGrpSpPr>
+            <p:cNvPr id="17" name="Group 16">
+              <a:extLst>
+                <a:ext uri="{FF2B5EF4-FFF2-40B4-BE49-F238E27FC236}">
+                  <a16:creationId xmlns:a16="http://schemas.microsoft.com/office/drawing/2014/main" id="{3A9084E4-2E56-475E-5665-ACEDEF7B491D}"/>
+                </a:ext>
+              </a:extLst>
+            </p:cNvPr>
+            <p:cNvGrpSpPr/>
+            <p:nvPr/>
+          </p:nvGrpSpPr>
+          <p:grpSpPr>
+            <a:xfrm>
+              <a:off x="0" y="0"/>
+              <a:ext cx="7157187" cy="9144000"/>
+              <a:chOff x="-689" y="0"/>
+              <a:chExt cx="7157187" cy="9144000"/>
+            </a:xfrm>
+          </p:grpSpPr>
+          <p:sp>
+            <p:nvSpPr>
+              <p:cNvPr id="6" name="Rectangle 5">
+                <a:extLst>
+                  <a:ext uri="{FF2B5EF4-FFF2-40B4-BE49-F238E27FC236}">
+                    <a16:creationId xmlns:a16="http://schemas.microsoft.com/office/drawing/2014/main" id="{F90AEC03-8540-CE6C-8F88-E1A80E2F7BD5}"/>
+                  </a:ext>
+                </a:extLst>
+              </p:cNvPr>
+              <p:cNvSpPr/>
+              <p:nvPr/>
+            </p:nvSpPr>
+            <p:spPr>
+              <a:xfrm>
+                <a:off x="0" y="0"/>
+                <a:ext cx="7156498" cy="9144000"/>
+              </a:xfrm>
+              <a:prstGeom prst="rect">
+                <a:avLst/>
+              </a:prstGeom>
+              <a:solidFill>
+                <a:schemeClr val="bg1"/>
+              </a:solidFill>
+              <a:ln>
+                <a:noFill/>
+              </a:ln>
+            </p:spPr>
+            <p:style>
+              <a:lnRef idx="2">
+                <a:schemeClr val="accent1">
+                  <a:shade val="15000"/>
+                </a:schemeClr>
+              </a:lnRef>
+              <a:fillRef idx="1">
+                <a:schemeClr val="accent1"/>
+              </a:fillRef>
+              <a:effectRef idx="0">
+                <a:schemeClr val="accent1"/>
+              </a:effectRef>
+              <a:fontRef idx="minor">
+                <a:schemeClr val="lt1"/>
+              </a:fontRef>
+            </p:style>
+            <p:txBody>
+              <a:bodyPr rtlCol="0" anchor="ctr"/>
+              <a:lstStyle/>
+              <a:p>
+                <a:pPr algn="ctr"/>
+                <a:endParaRPr lang="en-CA"/>
+              </a:p>
+            </p:txBody>
+          </p:sp>
+          <p:pic>
+            <p:nvPicPr>
+              <p:cNvPr id="15" name="Picture 14" descr="A map of canada with different colored dots&#10;&#10;Description automatically generated">
+                <a:extLst>
+                  <a:ext uri="{FF2B5EF4-FFF2-40B4-BE49-F238E27FC236}">
+                    <a16:creationId xmlns:a16="http://schemas.microsoft.com/office/drawing/2014/main" id="{203793AC-96A4-7867-4CF8-35018737A5BD}"/>
+                  </a:ext>
+                </a:extLst>
+              </p:cNvPr>
+              <p:cNvPicPr>
+                <a:picLocks noChangeAspect="1"/>
+              </p:cNvPicPr>
+              <p:nvPr/>
+            </p:nvPicPr>
+            <p:blipFill>
+              <a:blip r:embed="rId2"/>
+              <a:srcRect l="6744" t="11539" r="21752" b="11957"/>
+              <a:stretch/>
+            </p:blipFill>
+            <p:spPr>
+              <a:xfrm>
+                <a:off x="307471" y="226603"/>
+                <a:ext cx="6125554" cy="5243176"/>
+              </a:xfrm>
+              <a:prstGeom prst="rect">
+                <a:avLst/>
+              </a:prstGeom>
+            </p:spPr>
+          </p:pic>
+          <p:pic>
+            <p:nvPicPr>
+              <p:cNvPr id="16" name="Picture 15" descr="A map of canada with different colored dots&#10;&#10;Description automatically generated">
+                <a:extLst>
+                  <a:ext uri="{FF2B5EF4-FFF2-40B4-BE49-F238E27FC236}">
+                    <a16:creationId xmlns:a16="http://schemas.microsoft.com/office/drawing/2014/main" id="{36EDABF0-6D7E-07D2-00BC-BA16357E5C02}"/>
+                  </a:ext>
+                </a:extLst>
+              </p:cNvPr>
+              <p:cNvPicPr>
+                <a:picLocks noChangeAspect="1"/>
+              </p:cNvPicPr>
+              <p:nvPr/>
+            </p:nvPicPr>
+            <p:blipFill>
+              <a:blip r:embed="rId2"/>
+              <a:srcRect l="82294" t="34757" r="4158" b="33883"/>
+              <a:stretch/>
+            </p:blipFill>
+            <p:spPr>
+              <a:xfrm>
+                <a:off x="5562857" y="273459"/>
+                <a:ext cx="1488499" cy="2756359"/>
+              </a:xfrm>
+              <a:prstGeom prst="rect">
+                <a:avLst/>
+              </a:prstGeom>
+            </p:spPr>
+          </p:pic>
+          <p:pic>
+            <p:nvPicPr>
+              <p:cNvPr id="7" name="Picture 6" descr="A graph with different colored bars&#10;&#10;Description automatically generated">
+                <a:extLst>
+                  <a:ext uri="{FF2B5EF4-FFF2-40B4-BE49-F238E27FC236}">
+                    <a16:creationId xmlns:a16="http://schemas.microsoft.com/office/drawing/2014/main" id="{1F1DC779-1B58-68A0-FE75-41C2982FAC1A}"/>
+                  </a:ext>
+                </a:extLst>
+              </p:cNvPr>
+              <p:cNvPicPr>
+                <a:picLocks noChangeAspect="1"/>
+              </p:cNvPicPr>
+              <p:nvPr/>
+            </p:nvPicPr>
+            <p:blipFill>
+              <a:blip r:embed="rId3"/>
+              <a:srcRect t="13750" b="13520"/>
+              <a:stretch/>
+            </p:blipFill>
+            <p:spPr>
+              <a:xfrm>
+                <a:off x="-689" y="5519886"/>
+                <a:ext cx="7055238" cy="3180038"/>
+              </a:xfrm>
+              <a:prstGeom prst="rect">
+                <a:avLst/>
+              </a:prstGeom>
+            </p:spPr>
+          </p:pic>
+          <p:sp>
+            <p:nvSpPr>
+              <p:cNvPr id="8" name="TextBox 7">
+                <a:extLst>
+                  <a:ext uri="{FF2B5EF4-FFF2-40B4-BE49-F238E27FC236}">
+                    <a16:creationId xmlns:a16="http://schemas.microsoft.com/office/drawing/2014/main" id="{B86CEB64-D298-9DE4-0905-86090688D8D3}"/>
+                  </a:ext>
+                </a:extLst>
+              </p:cNvPr>
+              <p:cNvSpPr txBox="1"/>
+              <p:nvPr/>
+            </p:nvSpPr>
+            <p:spPr>
+              <a:xfrm>
+                <a:off x="4642593" y="8700594"/>
+                <a:ext cx="2133918" cy="338554"/>
+              </a:xfrm>
+              <a:prstGeom prst="rect">
+                <a:avLst/>
+              </a:prstGeom>
+              <a:solidFill>
+                <a:schemeClr val="bg1"/>
+              </a:solidFill>
+            </p:spPr>
+            <p:txBody>
+              <a:bodyPr wrap="none" rtlCol="0">
+                <a:spAutoFit/>
+              </a:bodyPr>
+              <a:lstStyle/>
+              <a:p>
+                <a:r>
+                  <a:rPr lang="en-CA" sz="1600" b="1" dirty="0">
+                    <a:latin typeface="Roboto Condensed" pitchFamily="2" charset="0"/>
+                    <a:ea typeface="Roboto Condensed" pitchFamily="2" charset="0"/>
+                  </a:rPr>
+                  <a:t>Newly recorded species</a:t>
+                </a:r>
+              </a:p>
+            </p:txBody>
+          </p:sp>
+          <p:pic>
+            <p:nvPicPr>
+              <p:cNvPr id="4" name="Picture 3" descr="A map of canada with different colored dots&#10;&#10;Description automatically generated">
+                <a:extLst>
+                  <a:ext uri="{FF2B5EF4-FFF2-40B4-BE49-F238E27FC236}">
+                    <a16:creationId xmlns:a16="http://schemas.microsoft.com/office/drawing/2014/main" id="{EA2AA5E3-2431-6E14-8646-F2C6319A2548}"/>
+                  </a:ext>
+                </a:extLst>
+              </p:cNvPr>
+              <p:cNvPicPr>
+                <a:picLocks noChangeAspect="1"/>
+              </p:cNvPicPr>
+              <p:nvPr/>
+            </p:nvPicPr>
+            <p:blipFill>
+              <a:blip r:embed="rId4"/>
+              <a:srcRect l="83327" t="34490" r="2753" b="32364"/>
+              <a:stretch/>
+            </p:blipFill>
+            <p:spPr>
+              <a:xfrm>
+                <a:off x="5667999" y="274129"/>
+                <a:ext cx="1488499" cy="2756359"/>
+              </a:xfrm>
+              <a:prstGeom prst="rect">
+                <a:avLst/>
+              </a:prstGeom>
+            </p:spPr>
+          </p:pic>
+          <p:sp>
+            <p:nvSpPr>
+              <p:cNvPr id="11" name="TextBox 10">
+                <a:extLst>
+                  <a:ext uri="{FF2B5EF4-FFF2-40B4-BE49-F238E27FC236}">
+                    <a16:creationId xmlns:a16="http://schemas.microsoft.com/office/drawing/2014/main" id="{F8A02C20-89FD-62A9-B5ED-F8E9D842E414}"/>
+                  </a:ext>
+                </a:extLst>
+              </p:cNvPr>
+              <p:cNvSpPr txBox="1"/>
+              <p:nvPr/>
+            </p:nvSpPr>
+            <p:spPr>
+              <a:xfrm>
+                <a:off x="164601" y="302145"/>
+                <a:ext cx="348172" cy="461665"/>
+              </a:xfrm>
+              <a:prstGeom prst="rect">
+                <a:avLst/>
+              </a:prstGeom>
+              <a:noFill/>
+            </p:spPr>
+            <p:txBody>
+              <a:bodyPr wrap="none" rtlCol="0">
+                <a:spAutoFit/>
+              </a:bodyPr>
+              <a:lstStyle/>
+              <a:p>
+                <a:r>
+                  <a:rPr lang="en-CA" sz="2400" dirty="0"/>
+                  <a:t>a</a:t>
+                </a:r>
+              </a:p>
+            </p:txBody>
+          </p:sp>
+          <p:sp>
+            <p:nvSpPr>
+              <p:cNvPr id="12" name="TextBox 11">
+                <a:extLst>
+                  <a:ext uri="{FF2B5EF4-FFF2-40B4-BE49-F238E27FC236}">
+                    <a16:creationId xmlns:a16="http://schemas.microsoft.com/office/drawing/2014/main" id="{A69D2971-03F7-EDBC-C106-05CC2F6B14FE}"/>
+                  </a:ext>
+                </a:extLst>
+              </p:cNvPr>
+              <p:cNvSpPr txBox="1"/>
+              <p:nvPr/>
+            </p:nvSpPr>
+            <p:spPr>
+              <a:xfrm>
+                <a:off x="154983" y="5465549"/>
+                <a:ext cx="357790" cy="461665"/>
+              </a:xfrm>
+              <a:prstGeom prst="rect">
+                <a:avLst/>
+              </a:prstGeom>
+              <a:noFill/>
+            </p:spPr>
+            <p:txBody>
+              <a:bodyPr wrap="none" rtlCol="0">
+                <a:spAutoFit/>
+              </a:bodyPr>
+              <a:lstStyle/>
+              <a:p>
+                <a:r>
+                  <a:rPr lang="en-CA" sz="2400" dirty="0"/>
+                  <a:t>b</a:t>
+                </a:r>
+              </a:p>
+            </p:txBody>
+          </p:sp>
+        </p:grpSp>
+        <p:sp>
+          <p:nvSpPr>
+            <p:cNvPr id="2" name="TextBox 1">
+              <a:extLst>
+                <a:ext uri="{FF2B5EF4-FFF2-40B4-BE49-F238E27FC236}">
+                  <a16:creationId xmlns:a16="http://schemas.microsoft.com/office/drawing/2014/main" id="{5DE14D92-1C65-8C2F-2318-6A31BEA31867}"/>
+                </a:ext>
+              </a:extLst>
+            </p:cNvPr>
+            <p:cNvSpPr txBox="1"/>
+            <p:nvPr/>
+          </p:nvSpPr>
+          <p:spPr>
+            <a:xfrm>
+              <a:off x="5932759" y="2008094"/>
+              <a:ext cx="1135247" cy="292388"/>
+            </a:xfrm>
+            <a:prstGeom prst="rect">
+              <a:avLst/>
+            </a:prstGeom>
+            <a:solidFill>
+              <a:schemeClr val="bg1"/>
+            </a:solidFill>
+          </p:spPr>
+          <p:txBody>
+            <a:bodyPr wrap="none" rtlCol="0">
+              <a:spAutoFit/>
+            </a:bodyPr>
+            <a:lstStyle/>
+            <a:p>
+              <a:r>
+                <a:rPr lang="en-CA" sz="1300" dirty="0">
+                  <a:latin typeface="Roboto Condensed Light" pitchFamily="2" charset="0"/>
+                  <a:ea typeface="Roboto Condensed Light" pitchFamily="2" charset="0"/>
+                </a:rPr>
+                <a:t>Other Animalia</a:t>
+              </a:r>
+            </a:p>
+          </p:txBody>
+        </p:sp>
+        <p:sp>
+          <p:nvSpPr>
+            <p:cNvPr id="3" name="TextBox 2">
+              <a:extLst>
+                <a:ext uri="{FF2B5EF4-FFF2-40B4-BE49-F238E27FC236}">
+                  <a16:creationId xmlns:a16="http://schemas.microsoft.com/office/drawing/2014/main" id="{0397D6E9-CDED-BC51-8A65-4F4D9AD76698}"/>
+                </a:ext>
+              </a:extLst>
+            </p:cNvPr>
+            <p:cNvSpPr txBox="1"/>
+            <p:nvPr/>
+          </p:nvSpPr>
+          <p:spPr>
+            <a:xfrm>
+              <a:off x="5932759" y="261233"/>
+              <a:ext cx="667170" cy="292388"/>
+            </a:xfrm>
+            <a:prstGeom prst="rect">
+              <a:avLst/>
+            </a:prstGeom>
+            <a:solidFill>
+              <a:schemeClr val="bg1"/>
+            </a:solidFill>
+          </p:spPr>
+          <p:txBody>
+            <a:bodyPr wrap="none" rtlCol="0">
+              <a:spAutoFit/>
+            </a:bodyPr>
+            <a:lstStyle/>
+            <a:p>
+              <a:r>
+                <a:rPr lang="en-CA" sz="1300" dirty="0">
+                  <a:latin typeface="Roboto Condensed Light" pitchFamily="2" charset="0"/>
+                  <a:ea typeface="Roboto Condensed Light" pitchFamily="2" charset="0"/>
+                </a:rPr>
+                <a:t>Reptilia</a:t>
+              </a:r>
+            </a:p>
+          </p:txBody>
+        </p:sp>
+        <p:sp>
+          <p:nvSpPr>
+            <p:cNvPr id="5" name="TextBox 4">
+              <a:extLst>
+                <a:ext uri="{FF2B5EF4-FFF2-40B4-BE49-F238E27FC236}">
+                  <a16:creationId xmlns:a16="http://schemas.microsoft.com/office/drawing/2014/main" id="{A42F3032-7FC9-F683-D79D-1DD7738998DD}"/>
+                </a:ext>
+              </a:extLst>
+            </p:cNvPr>
+            <p:cNvSpPr txBox="1"/>
+            <p:nvPr/>
+          </p:nvSpPr>
+          <p:spPr>
+            <a:xfrm>
+              <a:off x="5932759" y="521421"/>
+              <a:ext cx="497252" cy="292388"/>
+            </a:xfrm>
+            <a:prstGeom prst="rect">
+              <a:avLst/>
+            </a:prstGeom>
+            <a:solidFill>
+              <a:schemeClr val="bg1"/>
+            </a:solidFill>
+          </p:spPr>
+          <p:txBody>
+            <a:bodyPr wrap="none" rtlCol="0">
+              <a:spAutoFit/>
+            </a:bodyPr>
+            <a:lstStyle/>
+            <a:p>
+              <a:r>
+                <a:rPr lang="en-CA" sz="1300" dirty="0">
+                  <a:latin typeface="Roboto Condensed Light" pitchFamily="2" charset="0"/>
+                  <a:ea typeface="Roboto Condensed Light" pitchFamily="2" charset="0"/>
+                </a:rPr>
+                <a:t>Aves</a:t>
+              </a:r>
+            </a:p>
+          </p:txBody>
+        </p:sp>
+        <p:sp>
+          <p:nvSpPr>
+            <p:cNvPr id="9" name="TextBox 8">
+              <a:extLst>
+                <a:ext uri="{FF2B5EF4-FFF2-40B4-BE49-F238E27FC236}">
+                  <a16:creationId xmlns:a16="http://schemas.microsoft.com/office/drawing/2014/main" id="{3AD3C98B-2143-C88A-BEE1-231CD6315C7D}"/>
+                </a:ext>
+              </a:extLst>
+            </p:cNvPr>
+            <p:cNvSpPr txBox="1"/>
+            <p:nvPr/>
+          </p:nvSpPr>
+          <p:spPr>
+            <a:xfrm>
+              <a:off x="5932759" y="752254"/>
+              <a:ext cx="1075936" cy="292388"/>
+            </a:xfrm>
+            <a:prstGeom prst="rect">
+              <a:avLst/>
+            </a:prstGeom>
+            <a:solidFill>
+              <a:schemeClr val="bg1"/>
+            </a:solidFill>
+          </p:spPr>
+          <p:txBody>
+            <a:bodyPr wrap="none" rtlCol="0">
+              <a:spAutoFit/>
+            </a:bodyPr>
+            <a:lstStyle/>
+            <a:p>
+              <a:r>
+                <a:rPr lang="en-CA" sz="1300" dirty="0">
+                  <a:latin typeface="Roboto Condensed Light" pitchFamily="2" charset="0"/>
+                  <a:ea typeface="Roboto Condensed Light" pitchFamily="2" charset="0"/>
+                </a:rPr>
+                <a:t>Actinopterygii</a:t>
+              </a:r>
+            </a:p>
+          </p:txBody>
+        </p:sp>
+        <p:sp>
+          <p:nvSpPr>
+            <p:cNvPr id="10" name="TextBox 9">
+              <a:extLst>
+                <a:ext uri="{FF2B5EF4-FFF2-40B4-BE49-F238E27FC236}">
+                  <a16:creationId xmlns:a16="http://schemas.microsoft.com/office/drawing/2014/main" id="{09A19744-52C8-55A3-C67E-DB194788A8AA}"/>
+                </a:ext>
+              </a:extLst>
+            </p:cNvPr>
+            <p:cNvSpPr txBox="1"/>
+            <p:nvPr/>
+          </p:nvSpPr>
+          <p:spPr>
+            <a:xfrm>
+              <a:off x="5932759" y="1010841"/>
+              <a:ext cx="769763" cy="292388"/>
+            </a:xfrm>
+            <a:prstGeom prst="rect">
+              <a:avLst/>
+            </a:prstGeom>
+            <a:solidFill>
+              <a:schemeClr val="bg1"/>
+            </a:solidFill>
+          </p:spPr>
+          <p:txBody>
+            <a:bodyPr wrap="none" rtlCol="0">
+              <a:spAutoFit/>
+            </a:bodyPr>
+            <a:lstStyle/>
+            <a:p>
+              <a:r>
+                <a:rPr lang="en-CA" sz="1300" dirty="0">
+                  <a:latin typeface="Roboto Condensed Light" pitchFamily="2" charset="0"/>
+                  <a:ea typeface="Roboto Condensed Light" pitchFamily="2" charset="0"/>
+                </a:rPr>
+                <a:t>Mollusca</a:t>
+              </a:r>
+            </a:p>
+          </p:txBody>
+        </p:sp>
+        <p:sp>
+          <p:nvSpPr>
+            <p:cNvPr id="13" name="TextBox 12">
+              <a:extLst>
+                <a:ext uri="{FF2B5EF4-FFF2-40B4-BE49-F238E27FC236}">
+                  <a16:creationId xmlns:a16="http://schemas.microsoft.com/office/drawing/2014/main" id="{A39B90F9-515A-E93B-EDC6-4025B65C9569}"/>
+                </a:ext>
+              </a:extLst>
+            </p:cNvPr>
+            <p:cNvSpPr txBox="1"/>
+            <p:nvPr/>
+          </p:nvSpPr>
+          <p:spPr>
+            <a:xfrm>
+              <a:off x="5932759" y="1257338"/>
+              <a:ext cx="835485" cy="292388"/>
+            </a:xfrm>
+            <a:prstGeom prst="rect">
+              <a:avLst/>
+            </a:prstGeom>
+            <a:solidFill>
+              <a:schemeClr val="bg1"/>
+            </a:solidFill>
+          </p:spPr>
+          <p:txBody>
+            <a:bodyPr wrap="none" rtlCol="0">
+              <a:spAutoFit/>
+            </a:bodyPr>
+            <a:lstStyle/>
+            <a:p>
+              <a:r>
+                <a:rPr lang="en-CA" sz="1300" dirty="0">
+                  <a:latin typeface="Roboto Condensed Light" pitchFamily="2" charset="0"/>
+                  <a:ea typeface="Roboto Condensed Light" pitchFamily="2" charset="0"/>
+                </a:rPr>
+                <a:t>Arachnida</a:t>
+              </a:r>
+            </a:p>
+          </p:txBody>
+        </p:sp>
+        <p:sp>
+          <p:nvSpPr>
+            <p:cNvPr id="14" name="TextBox 13">
+              <a:extLst>
+                <a:ext uri="{FF2B5EF4-FFF2-40B4-BE49-F238E27FC236}">
+                  <a16:creationId xmlns:a16="http://schemas.microsoft.com/office/drawing/2014/main" id="{64675875-E4A8-6C86-6F1A-DA3697D5ADBA}"/>
+                </a:ext>
+              </a:extLst>
+            </p:cNvPr>
+            <p:cNvSpPr txBox="1"/>
+            <p:nvPr/>
+          </p:nvSpPr>
+          <p:spPr>
+            <a:xfrm>
+              <a:off x="5932759" y="1502080"/>
+              <a:ext cx="768159" cy="292388"/>
+            </a:xfrm>
+            <a:prstGeom prst="rect">
+              <a:avLst/>
+            </a:prstGeom>
+            <a:solidFill>
+              <a:schemeClr val="bg1"/>
+            </a:solidFill>
+          </p:spPr>
+          <p:txBody>
+            <a:bodyPr wrap="none" rtlCol="0">
+              <a:spAutoFit/>
+            </a:bodyPr>
+            <a:lstStyle/>
+            <a:p>
+              <a:r>
+                <a:rPr lang="en-CA" sz="1300" dirty="0">
+                  <a:latin typeface="Roboto Condensed Light" pitchFamily="2" charset="0"/>
+                  <a:ea typeface="Roboto Condensed Light" pitchFamily="2" charset="0"/>
+                </a:rPr>
+                <a:t>Protozoa</a:t>
+              </a:r>
+            </a:p>
+          </p:txBody>
+        </p:sp>
+        <p:sp>
+          <p:nvSpPr>
+            <p:cNvPr id="18" name="TextBox 17">
+              <a:extLst>
+                <a:ext uri="{FF2B5EF4-FFF2-40B4-BE49-F238E27FC236}">
+                  <a16:creationId xmlns:a16="http://schemas.microsoft.com/office/drawing/2014/main" id="{98B2AF8E-B5F4-E9E4-EA99-C635E78B412F}"/>
+                </a:ext>
+              </a:extLst>
+            </p:cNvPr>
+            <p:cNvSpPr txBox="1"/>
+            <p:nvPr/>
+          </p:nvSpPr>
+          <p:spPr>
+            <a:xfrm>
+              <a:off x="5932759" y="1755087"/>
+              <a:ext cx="853119" cy="292388"/>
+            </a:xfrm>
+            <a:prstGeom prst="rect">
+              <a:avLst/>
+            </a:prstGeom>
+            <a:solidFill>
+              <a:schemeClr val="bg1"/>
+            </a:solidFill>
+          </p:spPr>
+          <p:txBody>
+            <a:bodyPr wrap="none" rtlCol="0">
+              <a:spAutoFit/>
+            </a:bodyPr>
+            <a:lstStyle/>
+            <a:p>
+              <a:r>
+                <a:rPr lang="en-CA" sz="1300" dirty="0">
+                  <a:latin typeface="Roboto Condensed Light" pitchFamily="2" charset="0"/>
+                  <a:ea typeface="Roboto Condensed Light" pitchFamily="2" charset="0"/>
+                </a:rPr>
+                <a:t>Chromista</a:t>
+              </a:r>
+            </a:p>
+          </p:txBody>
+        </p:sp>
+        <p:sp>
+          <p:nvSpPr>
+            <p:cNvPr id="19" name="TextBox 18">
+              <a:extLst>
+                <a:ext uri="{FF2B5EF4-FFF2-40B4-BE49-F238E27FC236}">
+                  <a16:creationId xmlns:a16="http://schemas.microsoft.com/office/drawing/2014/main" id="{3624AABB-3968-3CAA-6510-7D3895BBD36E}"/>
+                </a:ext>
+              </a:extLst>
+            </p:cNvPr>
+            <p:cNvSpPr txBox="1"/>
+            <p:nvPr/>
+          </p:nvSpPr>
+          <p:spPr>
+            <a:xfrm>
+              <a:off x="5932759" y="2256323"/>
+              <a:ext cx="671979" cy="292388"/>
+            </a:xfrm>
+            <a:prstGeom prst="rect">
+              <a:avLst/>
+            </a:prstGeom>
+            <a:solidFill>
+              <a:schemeClr val="bg1"/>
+            </a:solidFill>
+          </p:spPr>
+          <p:txBody>
+            <a:bodyPr wrap="none" rtlCol="0">
+              <a:spAutoFit/>
+            </a:bodyPr>
+            <a:lstStyle/>
+            <a:p>
+              <a:r>
+                <a:rPr lang="en-CA" sz="1300" dirty="0">
+                  <a:latin typeface="Roboto Condensed Light" pitchFamily="2" charset="0"/>
+                  <a:ea typeface="Roboto Condensed Light" pitchFamily="2" charset="0"/>
+                </a:rPr>
+                <a:t>Plantae</a:t>
+              </a:r>
+            </a:p>
+          </p:txBody>
+        </p:sp>
+        <p:sp>
+          <p:nvSpPr>
+            <p:cNvPr id="20" name="TextBox 19">
+              <a:extLst>
+                <a:ext uri="{FF2B5EF4-FFF2-40B4-BE49-F238E27FC236}">
+                  <a16:creationId xmlns:a16="http://schemas.microsoft.com/office/drawing/2014/main" id="{92D3193D-BCAD-6159-14A5-ADE6F5ADFAE4}"/>
+                </a:ext>
+              </a:extLst>
+            </p:cNvPr>
+            <p:cNvSpPr txBox="1"/>
+            <p:nvPr/>
+          </p:nvSpPr>
+          <p:spPr>
+            <a:xfrm>
+              <a:off x="5932759" y="2498792"/>
+              <a:ext cx="543739" cy="292388"/>
+            </a:xfrm>
+            <a:prstGeom prst="rect">
+              <a:avLst/>
+            </a:prstGeom>
+            <a:solidFill>
+              <a:schemeClr val="bg1"/>
+            </a:solidFill>
+          </p:spPr>
+          <p:txBody>
+            <a:bodyPr wrap="none" rtlCol="0">
+              <a:spAutoFit/>
+            </a:bodyPr>
+            <a:lstStyle/>
+            <a:p>
+              <a:r>
+                <a:rPr lang="en-CA" sz="1300" dirty="0">
+                  <a:latin typeface="Roboto Condensed Light" pitchFamily="2" charset="0"/>
+                  <a:ea typeface="Roboto Condensed Light" pitchFamily="2" charset="0"/>
+                </a:rPr>
+                <a:t>Fungi</a:t>
+              </a:r>
+            </a:p>
+          </p:txBody>
+        </p:sp>
+        <p:sp>
+          <p:nvSpPr>
+            <p:cNvPr id="21" name="TextBox 20">
+              <a:extLst>
+                <a:ext uri="{FF2B5EF4-FFF2-40B4-BE49-F238E27FC236}">
+                  <a16:creationId xmlns:a16="http://schemas.microsoft.com/office/drawing/2014/main" id="{9E08AC59-B909-3653-4867-53059358F48F}"/>
+                </a:ext>
+              </a:extLst>
+            </p:cNvPr>
+            <p:cNvSpPr txBox="1"/>
+            <p:nvPr/>
+          </p:nvSpPr>
+          <p:spPr>
+            <a:xfrm>
+              <a:off x="5932759" y="2751307"/>
+              <a:ext cx="657552" cy="292388"/>
+            </a:xfrm>
+            <a:prstGeom prst="rect">
+              <a:avLst/>
+            </a:prstGeom>
+            <a:solidFill>
+              <a:schemeClr val="bg1"/>
+            </a:solidFill>
+          </p:spPr>
+          <p:txBody>
+            <a:bodyPr wrap="none" rtlCol="0">
+              <a:spAutoFit/>
+            </a:bodyPr>
+            <a:lstStyle/>
+            <a:p>
+              <a:r>
+                <a:rPr lang="en-CA" sz="1300" dirty="0">
+                  <a:latin typeface="Roboto Condensed Light" pitchFamily="2" charset="0"/>
+                  <a:ea typeface="Roboto Condensed Light" pitchFamily="2" charset="0"/>
+                </a:rPr>
+                <a:t>Insecta</a:t>
+              </a:r>
+            </a:p>
+          </p:txBody>
+        </p:sp>
+        <p:sp>
+          <p:nvSpPr>
+            <p:cNvPr id="22" name="TextBox 21">
+              <a:extLst>
+                <a:ext uri="{FF2B5EF4-FFF2-40B4-BE49-F238E27FC236}">
+                  <a16:creationId xmlns:a16="http://schemas.microsoft.com/office/drawing/2014/main" id="{373448A7-4129-B3CA-7751-4D2F0E51E64C}"/>
+                </a:ext>
+              </a:extLst>
+            </p:cNvPr>
+            <p:cNvSpPr txBox="1"/>
+            <p:nvPr/>
+          </p:nvSpPr>
+          <p:spPr>
+            <a:xfrm>
+              <a:off x="5927112" y="2011536"/>
+              <a:ext cx="1135247" cy="292388"/>
+            </a:xfrm>
+            <a:prstGeom prst="rect">
+              <a:avLst/>
+            </a:prstGeom>
+            <a:solidFill>
+              <a:schemeClr val="bg1"/>
+            </a:solidFill>
+          </p:spPr>
+          <p:txBody>
+            <a:bodyPr wrap="none" rtlCol="0">
+              <a:spAutoFit/>
+            </a:bodyPr>
+            <a:lstStyle/>
+            <a:p>
+              <a:r>
+                <a:rPr lang="en-CA" sz="1300" dirty="0">
+                  <a:latin typeface="Roboto Condensed Light" pitchFamily="2" charset="0"/>
+                  <a:ea typeface="Roboto Condensed Light" pitchFamily="2" charset="0"/>
+                </a:rPr>
+                <a:t>Other Animalia</a:t>
+              </a:r>
+            </a:p>
+          </p:txBody>
+        </p:sp>
+        <p:sp>
+          <p:nvSpPr>
+            <p:cNvPr id="23" name="TextBox 22">
+              <a:extLst>
+                <a:ext uri="{FF2B5EF4-FFF2-40B4-BE49-F238E27FC236}">
+                  <a16:creationId xmlns:a16="http://schemas.microsoft.com/office/drawing/2014/main" id="{12259634-12D7-CB3B-D99A-8182C7BF49DE}"/>
+                </a:ext>
+              </a:extLst>
+            </p:cNvPr>
+            <p:cNvSpPr txBox="1"/>
+            <p:nvPr/>
+          </p:nvSpPr>
+          <p:spPr>
+            <a:xfrm>
+              <a:off x="5927112" y="268487"/>
+              <a:ext cx="667170" cy="292388"/>
+            </a:xfrm>
+            <a:prstGeom prst="rect">
+              <a:avLst/>
+            </a:prstGeom>
+            <a:solidFill>
+              <a:schemeClr val="bg1"/>
+            </a:solidFill>
+          </p:spPr>
+          <p:txBody>
+            <a:bodyPr wrap="none" rtlCol="0">
+              <a:spAutoFit/>
+            </a:bodyPr>
+            <a:lstStyle/>
+            <a:p>
+              <a:r>
+                <a:rPr lang="en-CA" sz="1300" dirty="0">
+                  <a:latin typeface="Roboto Condensed Light" pitchFamily="2" charset="0"/>
+                  <a:ea typeface="Roboto Condensed Light" pitchFamily="2" charset="0"/>
+                </a:rPr>
+                <a:t>Reptilia</a:t>
+              </a:r>
+            </a:p>
+          </p:txBody>
+        </p:sp>
+        <p:sp>
+          <p:nvSpPr>
+            <p:cNvPr id="24" name="TextBox 23">
+              <a:extLst>
+                <a:ext uri="{FF2B5EF4-FFF2-40B4-BE49-F238E27FC236}">
+                  <a16:creationId xmlns:a16="http://schemas.microsoft.com/office/drawing/2014/main" id="{349BAD10-49AE-CD4F-C351-3B55C8D47425}"/>
+                </a:ext>
+              </a:extLst>
+            </p:cNvPr>
+            <p:cNvSpPr txBox="1"/>
+            <p:nvPr/>
+          </p:nvSpPr>
+          <p:spPr>
+            <a:xfrm>
+              <a:off x="5927112" y="517494"/>
+              <a:ext cx="497252" cy="292388"/>
+            </a:xfrm>
+            <a:prstGeom prst="rect">
+              <a:avLst/>
+            </a:prstGeom>
+            <a:solidFill>
+              <a:schemeClr val="bg1"/>
+            </a:solidFill>
+          </p:spPr>
+          <p:txBody>
+            <a:bodyPr wrap="none" rtlCol="0">
+              <a:spAutoFit/>
+            </a:bodyPr>
+            <a:lstStyle/>
+            <a:p>
+              <a:r>
+                <a:rPr lang="en-CA" sz="1300" dirty="0">
+                  <a:latin typeface="Roboto Condensed Light" pitchFamily="2" charset="0"/>
+                  <a:ea typeface="Roboto Condensed Light" pitchFamily="2" charset="0"/>
+                </a:rPr>
+                <a:t>Aves</a:t>
+              </a:r>
+            </a:p>
+          </p:txBody>
+        </p:sp>
+        <p:sp>
+          <p:nvSpPr>
+            <p:cNvPr id="25" name="TextBox 24">
+              <a:extLst>
+                <a:ext uri="{FF2B5EF4-FFF2-40B4-BE49-F238E27FC236}">
+                  <a16:creationId xmlns:a16="http://schemas.microsoft.com/office/drawing/2014/main" id="{02DFDC25-1B1B-AE32-8CE5-63714767FFD7}"/>
+                </a:ext>
+              </a:extLst>
+            </p:cNvPr>
+            <p:cNvSpPr txBox="1"/>
+            <p:nvPr/>
+          </p:nvSpPr>
+          <p:spPr>
+            <a:xfrm>
+              <a:off x="5927112" y="766501"/>
+              <a:ext cx="1075936" cy="292388"/>
+            </a:xfrm>
+            <a:prstGeom prst="rect">
+              <a:avLst/>
+            </a:prstGeom>
+            <a:solidFill>
+              <a:schemeClr val="bg1"/>
+            </a:solidFill>
+          </p:spPr>
+          <p:txBody>
+            <a:bodyPr wrap="none" rtlCol="0">
+              <a:spAutoFit/>
+            </a:bodyPr>
+            <a:lstStyle/>
+            <a:p>
+              <a:r>
+                <a:rPr lang="en-CA" sz="1300" dirty="0">
+                  <a:latin typeface="Roboto Condensed Light" pitchFamily="2" charset="0"/>
+                  <a:ea typeface="Roboto Condensed Light" pitchFamily="2" charset="0"/>
+                </a:rPr>
+                <a:t>Actinopterygii</a:t>
+              </a:r>
+            </a:p>
+          </p:txBody>
+        </p:sp>
+        <p:sp>
+          <p:nvSpPr>
+            <p:cNvPr id="26" name="TextBox 25">
+              <a:extLst>
+                <a:ext uri="{FF2B5EF4-FFF2-40B4-BE49-F238E27FC236}">
+                  <a16:creationId xmlns:a16="http://schemas.microsoft.com/office/drawing/2014/main" id="{4DE6199F-FFE3-3C59-3279-A5B9AEE4338A}"/>
+                </a:ext>
+              </a:extLst>
+            </p:cNvPr>
+            <p:cNvSpPr txBox="1"/>
+            <p:nvPr/>
+          </p:nvSpPr>
+          <p:spPr>
+            <a:xfrm>
+              <a:off x="5927112" y="1015508"/>
+              <a:ext cx="769763" cy="292388"/>
+            </a:xfrm>
+            <a:prstGeom prst="rect">
+              <a:avLst/>
+            </a:prstGeom>
+            <a:solidFill>
+              <a:schemeClr val="bg1"/>
+            </a:solidFill>
+          </p:spPr>
+          <p:txBody>
+            <a:bodyPr wrap="none" rtlCol="0">
+              <a:spAutoFit/>
+            </a:bodyPr>
+            <a:lstStyle/>
+            <a:p>
+              <a:r>
+                <a:rPr lang="en-CA" sz="1300" dirty="0">
+                  <a:latin typeface="Roboto Condensed Light" pitchFamily="2" charset="0"/>
+                  <a:ea typeface="Roboto Condensed Light" pitchFamily="2" charset="0"/>
+                </a:rPr>
+                <a:t>Mollusca</a:t>
+              </a:r>
+            </a:p>
+          </p:txBody>
+        </p:sp>
+        <p:sp>
+          <p:nvSpPr>
+            <p:cNvPr id="27" name="TextBox 26">
+              <a:extLst>
+                <a:ext uri="{FF2B5EF4-FFF2-40B4-BE49-F238E27FC236}">
+                  <a16:creationId xmlns:a16="http://schemas.microsoft.com/office/drawing/2014/main" id="{1749414F-B500-24F9-8434-7AAECF7FD200}"/>
+                </a:ext>
+              </a:extLst>
+            </p:cNvPr>
+            <p:cNvSpPr txBox="1"/>
+            <p:nvPr/>
+          </p:nvSpPr>
+          <p:spPr>
+            <a:xfrm>
+              <a:off x="5927112" y="1264515"/>
+              <a:ext cx="835485" cy="292388"/>
+            </a:xfrm>
+            <a:prstGeom prst="rect">
+              <a:avLst/>
+            </a:prstGeom>
+            <a:solidFill>
+              <a:schemeClr val="bg1"/>
+            </a:solidFill>
+          </p:spPr>
+          <p:txBody>
+            <a:bodyPr wrap="none" rtlCol="0">
+              <a:spAutoFit/>
+            </a:bodyPr>
+            <a:lstStyle/>
+            <a:p>
+              <a:r>
+                <a:rPr lang="en-CA" sz="1300" dirty="0">
+                  <a:latin typeface="Roboto Condensed Light" pitchFamily="2" charset="0"/>
+                  <a:ea typeface="Roboto Condensed Light" pitchFamily="2" charset="0"/>
+                </a:rPr>
+                <a:t>Arachnida</a:t>
+              </a:r>
+            </a:p>
+          </p:txBody>
+        </p:sp>
+        <p:sp>
+          <p:nvSpPr>
+            <p:cNvPr id="28" name="TextBox 27">
+              <a:extLst>
+                <a:ext uri="{FF2B5EF4-FFF2-40B4-BE49-F238E27FC236}">
+                  <a16:creationId xmlns:a16="http://schemas.microsoft.com/office/drawing/2014/main" id="{56571E65-B768-6A78-906F-8FC16B4B9901}"/>
+                </a:ext>
+              </a:extLst>
+            </p:cNvPr>
+            <p:cNvSpPr txBox="1"/>
+            <p:nvPr/>
+          </p:nvSpPr>
+          <p:spPr>
+            <a:xfrm>
+              <a:off x="5927112" y="1513522"/>
+              <a:ext cx="768159" cy="292388"/>
+            </a:xfrm>
+            <a:prstGeom prst="rect">
+              <a:avLst/>
+            </a:prstGeom>
+            <a:solidFill>
+              <a:schemeClr val="bg1"/>
+            </a:solidFill>
+          </p:spPr>
+          <p:txBody>
+            <a:bodyPr wrap="none" rtlCol="0">
+              <a:spAutoFit/>
+            </a:bodyPr>
+            <a:lstStyle/>
+            <a:p>
+              <a:r>
+                <a:rPr lang="en-CA" sz="1300" dirty="0">
+                  <a:latin typeface="Roboto Condensed Light" pitchFamily="2" charset="0"/>
+                  <a:ea typeface="Roboto Condensed Light" pitchFamily="2" charset="0"/>
+                </a:rPr>
+                <a:t>Protozoa</a:t>
+              </a:r>
+            </a:p>
+          </p:txBody>
+        </p:sp>
+        <p:sp>
+          <p:nvSpPr>
+            <p:cNvPr id="29" name="TextBox 28">
+              <a:extLst>
+                <a:ext uri="{FF2B5EF4-FFF2-40B4-BE49-F238E27FC236}">
+                  <a16:creationId xmlns:a16="http://schemas.microsoft.com/office/drawing/2014/main" id="{5C9F696E-CD26-CFE4-DB6E-15ACB3B2E59A}"/>
+                </a:ext>
+              </a:extLst>
+            </p:cNvPr>
+            <p:cNvSpPr txBox="1"/>
+            <p:nvPr/>
+          </p:nvSpPr>
+          <p:spPr>
+            <a:xfrm>
+              <a:off x="5927112" y="1762529"/>
+              <a:ext cx="853119" cy="292388"/>
+            </a:xfrm>
+            <a:prstGeom prst="rect">
+              <a:avLst/>
+            </a:prstGeom>
+            <a:solidFill>
+              <a:schemeClr val="bg1"/>
+            </a:solidFill>
+          </p:spPr>
+          <p:txBody>
+            <a:bodyPr wrap="none" rtlCol="0">
+              <a:spAutoFit/>
+            </a:bodyPr>
+            <a:lstStyle/>
+            <a:p>
+              <a:r>
+                <a:rPr lang="en-CA" sz="1300" dirty="0">
+                  <a:latin typeface="Roboto Condensed Light" pitchFamily="2" charset="0"/>
+                  <a:ea typeface="Roboto Condensed Light" pitchFamily="2" charset="0"/>
+                </a:rPr>
+                <a:t>Chromista</a:t>
+              </a:r>
+            </a:p>
+          </p:txBody>
+        </p:sp>
+        <p:sp>
+          <p:nvSpPr>
+            <p:cNvPr id="30" name="TextBox 29">
+              <a:extLst>
+                <a:ext uri="{FF2B5EF4-FFF2-40B4-BE49-F238E27FC236}">
+                  <a16:creationId xmlns:a16="http://schemas.microsoft.com/office/drawing/2014/main" id="{7B595873-4BFE-7610-22A4-C013DA5A05E7}"/>
+                </a:ext>
+              </a:extLst>
+            </p:cNvPr>
+            <p:cNvSpPr txBox="1"/>
+            <p:nvPr/>
+          </p:nvSpPr>
+          <p:spPr>
+            <a:xfrm>
+              <a:off x="5927112" y="2260543"/>
+              <a:ext cx="671979" cy="292388"/>
+            </a:xfrm>
+            <a:prstGeom prst="rect">
+              <a:avLst/>
+            </a:prstGeom>
+            <a:solidFill>
+              <a:schemeClr val="bg1"/>
+            </a:solidFill>
+          </p:spPr>
+          <p:txBody>
+            <a:bodyPr wrap="none" rtlCol="0">
+              <a:spAutoFit/>
+            </a:bodyPr>
+            <a:lstStyle/>
+            <a:p>
+              <a:r>
+                <a:rPr lang="en-CA" sz="1300" dirty="0">
+                  <a:latin typeface="Roboto Condensed Light" pitchFamily="2" charset="0"/>
+                  <a:ea typeface="Roboto Condensed Light" pitchFamily="2" charset="0"/>
+                </a:rPr>
+                <a:t>Plantae</a:t>
+              </a:r>
+            </a:p>
+          </p:txBody>
+        </p:sp>
+        <p:sp>
+          <p:nvSpPr>
+            <p:cNvPr id="31" name="TextBox 30">
+              <a:extLst>
+                <a:ext uri="{FF2B5EF4-FFF2-40B4-BE49-F238E27FC236}">
+                  <a16:creationId xmlns:a16="http://schemas.microsoft.com/office/drawing/2014/main" id="{DE6B84C1-0DCE-9432-D11C-BAECC980637A}"/>
+                </a:ext>
+              </a:extLst>
+            </p:cNvPr>
+            <p:cNvSpPr txBox="1"/>
+            <p:nvPr/>
+          </p:nvSpPr>
+          <p:spPr>
+            <a:xfrm>
+              <a:off x="5927112" y="2509550"/>
+              <a:ext cx="543739" cy="292388"/>
+            </a:xfrm>
+            <a:prstGeom prst="rect">
+              <a:avLst/>
+            </a:prstGeom>
+            <a:solidFill>
+              <a:schemeClr val="bg1"/>
+            </a:solidFill>
+          </p:spPr>
+          <p:txBody>
+            <a:bodyPr wrap="none" rtlCol="0">
+              <a:spAutoFit/>
+            </a:bodyPr>
+            <a:lstStyle/>
+            <a:p>
+              <a:r>
+                <a:rPr lang="en-CA" sz="1300" dirty="0">
+                  <a:latin typeface="Roboto Condensed Light" pitchFamily="2" charset="0"/>
+                  <a:ea typeface="Roboto Condensed Light" pitchFamily="2" charset="0"/>
+                </a:rPr>
+                <a:t>Fungi</a:t>
+              </a:r>
+            </a:p>
+          </p:txBody>
+        </p:sp>
+        <p:sp>
+          <p:nvSpPr>
+            <p:cNvPr id="32" name="TextBox 31">
+              <a:extLst>
+                <a:ext uri="{FF2B5EF4-FFF2-40B4-BE49-F238E27FC236}">
+                  <a16:creationId xmlns:a16="http://schemas.microsoft.com/office/drawing/2014/main" id="{32A4E6D5-A0C0-9E3F-D937-9A2738AE2BB1}"/>
+                </a:ext>
+              </a:extLst>
+            </p:cNvPr>
+            <p:cNvSpPr txBox="1"/>
+            <p:nvPr/>
+          </p:nvSpPr>
+          <p:spPr>
+            <a:xfrm>
+              <a:off x="5927112" y="2758561"/>
+              <a:ext cx="657552" cy="292388"/>
+            </a:xfrm>
+            <a:prstGeom prst="rect">
+              <a:avLst/>
+            </a:prstGeom>
+            <a:solidFill>
+              <a:schemeClr val="bg1"/>
+            </a:solidFill>
+          </p:spPr>
+          <p:txBody>
+            <a:bodyPr wrap="none" rtlCol="0">
+              <a:spAutoFit/>
+            </a:bodyPr>
+            <a:lstStyle/>
+            <a:p>
+              <a:r>
+                <a:rPr lang="en-CA" sz="1300" dirty="0">
+                  <a:latin typeface="Roboto Condensed Light" pitchFamily="2" charset="0"/>
+                  <a:ea typeface="Roboto Condensed Light" pitchFamily="2" charset="0"/>
+                </a:rPr>
+                <a:t>Insecta</a:t>
+              </a:r>
+            </a:p>
+          </p:txBody>
+        </p:sp>
+        <p:sp>
+          <p:nvSpPr>
+            <p:cNvPr id="44" name="TextBox 43">
+              <a:extLst>
+                <a:ext uri="{FF2B5EF4-FFF2-40B4-BE49-F238E27FC236}">
+                  <a16:creationId xmlns:a16="http://schemas.microsoft.com/office/drawing/2014/main" id="{38CB614E-3354-0747-42C8-FD975613BAB7}"/>
+                </a:ext>
+              </a:extLst>
+            </p:cNvPr>
+            <p:cNvSpPr txBox="1"/>
+            <p:nvPr/>
+          </p:nvSpPr>
+          <p:spPr>
+            <a:xfrm>
+              <a:off x="301396" y="6463261"/>
+              <a:ext cx="1530781" cy="307777"/>
+            </a:xfrm>
+            <a:prstGeom prst="rect">
+              <a:avLst/>
+            </a:prstGeom>
+            <a:solidFill>
+              <a:schemeClr val="bg1"/>
+            </a:solidFill>
+          </p:spPr>
+          <p:txBody>
+            <a:bodyPr wrap="square" rtlCol="0">
+              <a:spAutoFit/>
+            </a:bodyPr>
+            <a:lstStyle/>
+            <a:p>
+              <a:pPr algn="r"/>
+              <a:r>
+                <a:rPr lang="en-CA" sz="1400" dirty="0">
+                  <a:latin typeface="Roboto Condensed Light" pitchFamily="2" charset="0"/>
+                  <a:ea typeface="Roboto Condensed Light" pitchFamily="2" charset="0"/>
+                </a:rPr>
+                <a:t>Other Animalia</a:t>
+              </a:r>
+            </a:p>
+          </p:txBody>
+        </p:sp>
+        <p:sp>
+          <p:nvSpPr>
+            <p:cNvPr id="46" name="TextBox 45">
+              <a:extLst>
+                <a:ext uri="{FF2B5EF4-FFF2-40B4-BE49-F238E27FC236}">
+                  <a16:creationId xmlns:a16="http://schemas.microsoft.com/office/drawing/2014/main" id="{8A0F5B99-6741-2570-378B-A5F33EE6199B}"/>
+                </a:ext>
+              </a:extLst>
+            </p:cNvPr>
+            <p:cNvSpPr txBox="1"/>
+            <p:nvPr/>
+          </p:nvSpPr>
+          <p:spPr>
+            <a:xfrm>
+              <a:off x="1173000" y="8131493"/>
+              <a:ext cx="659177" cy="307777"/>
+            </a:xfrm>
+            <a:prstGeom prst="rect">
+              <a:avLst/>
+            </a:prstGeom>
+            <a:solidFill>
+              <a:schemeClr val="bg1"/>
+            </a:solidFill>
+          </p:spPr>
+          <p:txBody>
+            <a:bodyPr wrap="square" rtlCol="0">
+              <a:spAutoFit/>
+            </a:bodyPr>
+            <a:lstStyle/>
+            <a:p>
+              <a:pPr algn="r"/>
+              <a:r>
+                <a:rPr lang="en-CA" sz="1400" dirty="0">
+                  <a:latin typeface="Roboto Condensed Light" pitchFamily="2" charset="0"/>
+                  <a:ea typeface="Roboto Condensed Light" pitchFamily="2" charset="0"/>
+                </a:rPr>
+                <a:t>Aves</a:t>
+              </a:r>
+            </a:p>
+          </p:txBody>
+        </p:sp>
+        <p:sp>
+          <p:nvSpPr>
+            <p:cNvPr id="47" name="TextBox 46">
+              <a:extLst>
+                <a:ext uri="{FF2B5EF4-FFF2-40B4-BE49-F238E27FC236}">
+                  <a16:creationId xmlns:a16="http://schemas.microsoft.com/office/drawing/2014/main" id="{3863B680-7FC1-82DE-79EB-C2790ACC6898}"/>
+                </a:ext>
+              </a:extLst>
+            </p:cNvPr>
+            <p:cNvSpPr txBox="1"/>
+            <p:nvPr/>
+          </p:nvSpPr>
+          <p:spPr>
+            <a:xfrm>
+              <a:off x="388556" y="7853456"/>
+              <a:ext cx="1443621" cy="307777"/>
+            </a:xfrm>
+            <a:prstGeom prst="rect">
+              <a:avLst/>
+            </a:prstGeom>
+            <a:solidFill>
+              <a:schemeClr val="bg1"/>
+            </a:solidFill>
+          </p:spPr>
+          <p:txBody>
+            <a:bodyPr wrap="square" rtlCol="0">
+              <a:spAutoFit/>
+            </a:bodyPr>
+            <a:lstStyle/>
+            <a:p>
+              <a:pPr algn="r"/>
+              <a:r>
+                <a:rPr lang="en-CA" sz="1400" dirty="0">
+                  <a:latin typeface="Roboto Condensed Light" pitchFamily="2" charset="0"/>
+                  <a:ea typeface="Roboto Condensed Light" pitchFamily="2" charset="0"/>
+                </a:rPr>
+                <a:t>Actinopterygii</a:t>
+              </a:r>
+            </a:p>
+          </p:txBody>
+        </p:sp>
+        <p:sp>
+          <p:nvSpPr>
+            <p:cNvPr id="48" name="TextBox 47">
+              <a:extLst>
+                <a:ext uri="{FF2B5EF4-FFF2-40B4-BE49-F238E27FC236}">
+                  <a16:creationId xmlns:a16="http://schemas.microsoft.com/office/drawing/2014/main" id="{55FF6E3C-F8DC-A173-42F0-2E8CE7122CBA}"/>
+                </a:ext>
+              </a:extLst>
+            </p:cNvPr>
+            <p:cNvSpPr txBox="1"/>
+            <p:nvPr/>
+          </p:nvSpPr>
+          <p:spPr>
+            <a:xfrm>
+              <a:off x="798007" y="7297378"/>
+              <a:ext cx="1034170" cy="307777"/>
+            </a:xfrm>
+            <a:prstGeom prst="rect">
+              <a:avLst/>
+            </a:prstGeom>
+            <a:solidFill>
+              <a:schemeClr val="bg1"/>
+            </a:solidFill>
+          </p:spPr>
+          <p:txBody>
+            <a:bodyPr wrap="square" rtlCol="0">
+              <a:spAutoFit/>
+            </a:bodyPr>
+            <a:lstStyle/>
+            <a:p>
+              <a:pPr algn="r"/>
+              <a:r>
+                <a:rPr lang="en-CA" sz="1400" dirty="0">
+                  <a:latin typeface="Roboto Condensed Light" pitchFamily="2" charset="0"/>
+                  <a:ea typeface="Roboto Condensed Light" pitchFamily="2" charset="0"/>
+                </a:rPr>
+                <a:t>Mollusca</a:t>
+              </a:r>
+            </a:p>
+          </p:txBody>
+        </p:sp>
+        <p:sp>
+          <p:nvSpPr>
+            <p:cNvPr id="49" name="TextBox 48">
+              <a:extLst>
+                <a:ext uri="{FF2B5EF4-FFF2-40B4-BE49-F238E27FC236}">
+                  <a16:creationId xmlns:a16="http://schemas.microsoft.com/office/drawing/2014/main" id="{F853A98B-D0BB-DB4C-046E-3840BAE5C5EF}"/>
+                </a:ext>
+              </a:extLst>
+            </p:cNvPr>
+            <p:cNvSpPr txBox="1"/>
+            <p:nvPr/>
+          </p:nvSpPr>
+          <p:spPr>
+            <a:xfrm>
+              <a:off x="708820" y="7019339"/>
+              <a:ext cx="1123357" cy="307777"/>
+            </a:xfrm>
+            <a:prstGeom prst="rect">
+              <a:avLst/>
+            </a:prstGeom>
+            <a:solidFill>
+              <a:schemeClr val="bg1"/>
+            </a:solidFill>
+          </p:spPr>
+          <p:txBody>
+            <a:bodyPr wrap="square" rtlCol="0">
+              <a:spAutoFit/>
+            </a:bodyPr>
+            <a:lstStyle/>
+            <a:p>
+              <a:pPr algn="r"/>
+              <a:r>
+                <a:rPr lang="en-CA" sz="1400" dirty="0">
+                  <a:latin typeface="Roboto Condensed Light" pitchFamily="2" charset="0"/>
+                  <a:ea typeface="Roboto Condensed Light" pitchFamily="2" charset="0"/>
+                </a:rPr>
+                <a:t>Arachnida</a:t>
+              </a:r>
+            </a:p>
+          </p:txBody>
+        </p:sp>
+        <p:sp>
+          <p:nvSpPr>
+            <p:cNvPr id="50" name="TextBox 49">
+              <a:extLst>
+                <a:ext uri="{FF2B5EF4-FFF2-40B4-BE49-F238E27FC236}">
+                  <a16:creationId xmlns:a16="http://schemas.microsoft.com/office/drawing/2014/main" id="{6E8F8C97-6EAC-8B3F-ECC5-28B10A88E217}"/>
+                </a:ext>
+              </a:extLst>
+            </p:cNvPr>
+            <p:cNvSpPr txBox="1"/>
+            <p:nvPr/>
+          </p:nvSpPr>
+          <p:spPr>
+            <a:xfrm>
+              <a:off x="804089" y="7575417"/>
+              <a:ext cx="1028088" cy="307777"/>
+            </a:xfrm>
+            <a:prstGeom prst="rect">
+              <a:avLst/>
+            </a:prstGeom>
+            <a:solidFill>
+              <a:schemeClr val="bg1"/>
+            </a:solidFill>
+          </p:spPr>
+          <p:txBody>
+            <a:bodyPr wrap="square" rtlCol="0">
+              <a:spAutoFit/>
+            </a:bodyPr>
+            <a:lstStyle/>
+            <a:p>
+              <a:pPr algn="r"/>
+              <a:r>
+                <a:rPr lang="en-CA" sz="1400" dirty="0">
+                  <a:latin typeface="Roboto Condensed Light" pitchFamily="2" charset="0"/>
+                  <a:ea typeface="Roboto Condensed Light" pitchFamily="2" charset="0"/>
+                </a:rPr>
+                <a:t>Protozoa</a:t>
+              </a:r>
+            </a:p>
+          </p:txBody>
+        </p:sp>
+        <p:sp>
+          <p:nvSpPr>
+            <p:cNvPr id="51" name="TextBox 50">
+              <a:extLst>
+                <a:ext uri="{FF2B5EF4-FFF2-40B4-BE49-F238E27FC236}">
+                  <a16:creationId xmlns:a16="http://schemas.microsoft.com/office/drawing/2014/main" id="{BC9EFEF6-4051-3AB0-6172-EEC47A0F43F3}"/>
+                </a:ext>
+              </a:extLst>
+            </p:cNvPr>
+            <p:cNvSpPr txBox="1"/>
+            <p:nvPr/>
+          </p:nvSpPr>
+          <p:spPr>
+            <a:xfrm>
+              <a:off x="686524" y="6741300"/>
+              <a:ext cx="1145653" cy="307777"/>
+            </a:xfrm>
+            <a:prstGeom prst="rect">
+              <a:avLst/>
+            </a:prstGeom>
+            <a:solidFill>
+              <a:schemeClr val="bg1"/>
+            </a:solidFill>
+          </p:spPr>
+          <p:txBody>
+            <a:bodyPr wrap="square" rtlCol="0">
+              <a:spAutoFit/>
+            </a:bodyPr>
+            <a:lstStyle/>
+            <a:p>
+              <a:pPr algn="r"/>
+              <a:r>
+                <a:rPr lang="en-CA" sz="1400" dirty="0">
+                  <a:latin typeface="Roboto Condensed Light" pitchFamily="2" charset="0"/>
+                  <a:ea typeface="Roboto Condensed Light" pitchFamily="2" charset="0"/>
+                </a:rPr>
+                <a:t>Chromista</a:t>
+              </a:r>
+            </a:p>
+          </p:txBody>
+        </p:sp>
+        <p:sp>
+          <p:nvSpPr>
+            <p:cNvPr id="52" name="TextBox 51">
+              <a:extLst>
+                <a:ext uri="{FF2B5EF4-FFF2-40B4-BE49-F238E27FC236}">
+                  <a16:creationId xmlns:a16="http://schemas.microsoft.com/office/drawing/2014/main" id="{3AEAD868-7AA6-BBC2-0809-8410728D7DFE}"/>
+                </a:ext>
+              </a:extLst>
+            </p:cNvPr>
+            <p:cNvSpPr txBox="1"/>
+            <p:nvPr/>
+          </p:nvSpPr>
+          <p:spPr>
+            <a:xfrm>
+              <a:off x="935843" y="5907183"/>
+              <a:ext cx="896334" cy="307777"/>
+            </a:xfrm>
+            <a:prstGeom prst="rect">
+              <a:avLst/>
+            </a:prstGeom>
+            <a:solidFill>
+              <a:schemeClr val="bg1"/>
+            </a:solidFill>
+          </p:spPr>
+          <p:txBody>
+            <a:bodyPr wrap="square" rtlCol="0">
+              <a:spAutoFit/>
+            </a:bodyPr>
+            <a:lstStyle/>
+            <a:p>
+              <a:pPr algn="r"/>
+              <a:r>
+                <a:rPr lang="en-CA" sz="1400" dirty="0">
+                  <a:latin typeface="Roboto Condensed Light" pitchFamily="2" charset="0"/>
+                  <a:ea typeface="Roboto Condensed Light" pitchFamily="2" charset="0"/>
+                </a:rPr>
+                <a:t>Plantae</a:t>
+              </a:r>
+            </a:p>
+          </p:txBody>
+        </p:sp>
+        <p:sp>
+          <p:nvSpPr>
+            <p:cNvPr id="53" name="TextBox 52">
+              <a:extLst>
+                <a:ext uri="{FF2B5EF4-FFF2-40B4-BE49-F238E27FC236}">
+                  <a16:creationId xmlns:a16="http://schemas.microsoft.com/office/drawing/2014/main" id="{79CE1C46-8C24-0EEC-0B64-65DEF7FDC049}"/>
+                </a:ext>
+              </a:extLst>
+            </p:cNvPr>
+            <p:cNvSpPr txBox="1"/>
+            <p:nvPr/>
+          </p:nvSpPr>
+          <p:spPr>
+            <a:xfrm>
+              <a:off x="1110164" y="6185222"/>
+              <a:ext cx="722013" cy="307777"/>
+            </a:xfrm>
+            <a:prstGeom prst="rect">
+              <a:avLst/>
+            </a:prstGeom>
+            <a:solidFill>
+              <a:schemeClr val="bg1"/>
+            </a:solidFill>
+          </p:spPr>
+          <p:txBody>
+            <a:bodyPr wrap="square" rtlCol="0">
+              <a:spAutoFit/>
+            </a:bodyPr>
+            <a:lstStyle/>
+            <a:p>
+              <a:pPr algn="r"/>
+              <a:r>
+                <a:rPr lang="en-CA" sz="1400" dirty="0">
+                  <a:latin typeface="Roboto Condensed Light" pitchFamily="2" charset="0"/>
+                  <a:ea typeface="Roboto Condensed Light" pitchFamily="2" charset="0"/>
+                </a:rPr>
+                <a:t>Fungi</a:t>
+              </a:r>
+            </a:p>
+          </p:txBody>
+        </p:sp>
+        <p:sp>
+          <p:nvSpPr>
+            <p:cNvPr id="54" name="TextBox 53">
+              <a:extLst>
+                <a:ext uri="{FF2B5EF4-FFF2-40B4-BE49-F238E27FC236}">
+                  <a16:creationId xmlns:a16="http://schemas.microsoft.com/office/drawing/2014/main" id="{69AE2C10-D94E-A603-4F0C-CA8CE5D1E5AB}"/>
+                </a:ext>
+              </a:extLst>
+            </p:cNvPr>
+            <p:cNvSpPr txBox="1"/>
+            <p:nvPr/>
+          </p:nvSpPr>
+          <p:spPr>
+            <a:xfrm>
+              <a:off x="954086" y="5629144"/>
+              <a:ext cx="878091" cy="307777"/>
+            </a:xfrm>
+            <a:prstGeom prst="rect">
+              <a:avLst/>
+            </a:prstGeom>
+            <a:solidFill>
+              <a:schemeClr val="bg1"/>
+            </a:solidFill>
+          </p:spPr>
+          <p:txBody>
+            <a:bodyPr wrap="square" rtlCol="0">
+              <a:spAutoFit/>
+            </a:bodyPr>
+            <a:lstStyle/>
+            <a:p>
+              <a:pPr algn="r"/>
+              <a:r>
+                <a:rPr lang="en-CA" sz="1400" dirty="0">
+                  <a:latin typeface="Roboto Condensed Light" pitchFamily="2" charset="0"/>
+                  <a:ea typeface="Roboto Condensed Light" pitchFamily="2" charset="0"/>
+                </a:rPr>
+                <a:t>Insecta</a:t>
+              </a:r>
+            </a:p>
+          </p:txBody>
+        </p:sp>
+      </p:grpSp>
+    </p:spTree>
+    <p:extLst>
+      <p:ext uri="{BB962C8B-B14F-4D97-AF65-F5344CB8AC3E}">
+        <p14:creationId xmlns:p14="http://schemas.microsoft.com/office/powerpoint/2010/main" val="2769064776"/>
+      </p:ext>
+    </p:extLst>
+  </p:cSld>
+  <p:clrMapOvr>
+    <a:masterClrMapping/>
+  </p:clrMapOvr>
+</p:sld>
+</file>
+
+<file path=ppt/slides/slide3.xml><?xml version="1.0" encoding="utf-8"?>
 <p:sld xmlns:a="http://schemas.openxmlformats.org/drawingml/2006/main" xmlns:r="http://schemas.openxmlformats.org/officeDocument/2006/relationships" xmlns:p="http://schemas.openxmlformats.org/presentationml/2006/main">
   <p:cSld>
     <p:spTree>
@@ -3635,7 +5258,7 @@
 </p:sld>
 </file>
 
-<file path=ppt/slides/slide3.xml><?xml version="1.0" encoding="utf-8"?>
+<file path=ppt/slides/slide4.xml><?xml version="1.0" encoding="utf-8"?>
 <p:sld xmlns:a="http://schemas.openxmlformats.org/drawingml/2006/main" xmlns:r="http://schemas.openxmlformats.org/officeDocument/2006/relationships" xmlns:p="http://schemas.openxmlformats.org/presentationml/2006/main">
   <p:cSld>
     <p:spTree>

</xml_diff>